<commit_message>
Rebuild presentation with presenter notes
</commit_message>
<xml_diff>
--- a/GraphJudge_Presentation.pptx
+++ b/GraphJudge_Presentation.pptx
@@ -117,6 +117,1266 @@
     </a:lvl9pPr>
   </p:defaultTextStyle>
 </p:presentation>
+</file>
+
+<file path=ppt/notesMasters/notesMaster1.xml><?xml version="1.0" encoding="utf-8"?>
+<p:notesMaster xmlns:a="http://schemas.openxmlformats.org/drawingml/2006/main" xmlns:p="http://schemas.openxmlformats.org/presentationml/2006/main" xmlns:r="http://schemas.openxmlformats.org/officeDocument/2006/relationships">
+  <p:cSld>
+    <p:bg>
+      <p:bgRef idx="1001">
+        <a:schemeClr val="bg1"/>
+      </p:bgRef>
+    </p:bg>
+    <p:spTree>
+      <p:nvGrpSpPr>
+        <p:cNvPr id="1" name=""/>
+        <p:cNvGrpSpPr/>
+        <p:nvPr/>
+      </p:nvGrpSpPr>
+      <p:grpSpPr>
+        <a:xfrm>
+          <a:off x="0" y="0"/>
+          <a:ext cx="0" cy="0"/>
+          <a:chOff x="0" y="0"/>
+          <a:chExt cx="0" cy="0"/>
+        </a:xfrm>
+      </p:grpSpPr>
+      <p:sp>
+        <p:nvSpPr>
+          <p:cNvPr id="2" name="Header Placeholder 1"/>
+          <p:cNvSpPr>
+            <a:spLocks noGrp="1"/>
+          </p:cNvSpPr>
+          <p:nvPr>
+            <p:ph type="hdr" sz="quarter"/>
+          </p:nvPr>
+        </p:nvSpPr>
+        <p:spPr>
+          <a:xfrm>
+            <a:off x="0" y="0"/>
+            <a:ext cx="2971800" cy="457200"/>
+          </a:xfrm>
+          <a:prstGeom prst="rect">
+            <a:avLst/>
+          </a:prstGeom>
+        </p:spPr>
+        <p:txBody>
+          <a:bodyPr vert="horz" lIns="91440" tIns="45720" rIns="91440" bIns="45720" rtlCol="0"/>
+          <a:lstStyle>
+            <a:lvl1pPr algn="l">
+              <a:defRPr sz="1200"/>
+            </a:lvl1pPr>
+          </a:lstStyle>
+          <a:p>
+            <a:endParaRPr lang="en-US"/>
+          </a:p>
+        </p:txBody>
+      </p:sp>
+      <p:sp>
+        <p:nvSpPr>
+          <p:cNvPr id="3" name="Date Placeholder 2"/>
+          <p:cNvSpPr>
+            <a:spLocks noGrp="1"/>
+          </p:cNvSpPr>
+          <p:nvPr>
+            <p:ph type="dt" idx="1"/>
+          </p:nvPr>
+        </p:nvSpPr>
+        <p:spPr>
+          <a:xfrm>
+            <a:off x="3884613" y="0"/>
+            <a:ext cx="2971800" cy="457200"/>
+          </a:xfrm>
+          <a:prstGeom prst="rect">
+            <a:avLst/>
+          </a:prstGeom>
+        </p:spPr>
+        <p:txBody>
+          <a:bodyPr vert="horz" lIns="91440" tIns="45720" rIns="91440" bIns="45720" rtlCol="0"/>
+          <a:lstStyle>
+            <a:lvl1pPr algn="r">
+              <a:defRPr sz="1200"/>
+            </a:lvl1pPr>
+          </a:lstStyle>
+          <a:p>
+            <a:fld id="{0F89C1C7-3DCD-1040-A9CF-14679D8B5DDD}" type="datetimeFigureOut">
+              <a:rPr lang="en-US" smtClean="0"/>
+              <a:t>10/17/16</a:t>
+            </a:fld>
+            <a:endParaRPr lang="en-US"/>
+          </a:p>
+        </p:txBody>
+      </p:sp>
+      <p:sp>
+        <p:nvSpPr>
+          <p:cNvPr id="4" name="Slide Image Placeholder 3"/>
+          <p:cNvSpPr>
+            <a:spLocks noGrp="1" noRot="1" noChangeAspect="1"/>
+          </p:cNvSpPr>
+          <p:nvPr>
+            <p:ph type="sldImg" idx="2"/>
+          </p:nvPr>
+        </p:nvSpPr>
+        <p:spPr>
+          <a:xfrm>
+            <a:off x="1143000" y="685800"/>
+            <a:ext cx="4572000" cy="3429000"/>
+          </a:xfrm>
+          <a:prstGeom prst="rect">
+            <a:avLst/>
+          </a:prstGeom>
+          <a:noFill/>
+          <a:ln w="12700">
+            <a:solidFill>
+              <a:prstClr val="black"/>
+            </a:solidFill>
+          </a:ln>
+        </p:spPr>
+        <p:txBody>
+          <a:bodyPr vert="horz" lIns="91440" tIns="45720" rIns="91440" bIns="45720" rtlCol="0" anchor="ctr"/>
+          <a:lstStyle/>
+          <a:p>
+            <a:endParaRPr lang="en-US"/>
+          </a:p>
+        </p:txBody>
+      </p:sp>
+      <p:sp>
+        <p:nvSpPr>
+          <p:cNvPr id="5" name="Notes Placeholder 4"/>
+          <p:cNvSpPr>
+            <a:spLocks noGrp="1"/>
+          </p:cNvSpPr>
+          <p:nvPr>
+            <p:ph type="body" sz="quarter" idx="3"/>
+          </p:nvPr>
+        </p:nvSpPr>
+        <p:spPr>
+          <a:xfrm>
+            <a:off x="685800" y="4343400"/>
+            <a:ext cx="5486400" cy="4114800"/>
+          </a:xfrm>
+          <a:prstGeom prst="rect">
+            <a:avLst/>
+          </a:prstGeom>
+        </p:spPr>
+        <p:txBody>
+          <a:bodyPr vert="horz" lIns="91440" tIns="45720" rIns="91440" bIns="45720" rtlCol="0"/>
+          <a:lstStyle/>
+          <a:p>
+            <a:pPr lvl="0"/>
+            <a:r>
+              <a:rPr lang="en-US" smtClean="0"/>
+              <a:t>Click to edit Master text styles</a:t>
+            </a:r>
+          </a:p>
+          <a:p>
+            <a:pPr lvl="1"/>
+            <a:r>
+              <a:rPr lang="en-US" smtClean="0"/>
+              <a:t>Second level</a:t>
+            </a:r>
+          </a:p>
+          <a:p>
+            <a:pPr lvl="2"/>
+            <a:r>
+              <a:rPr lang="en-US" smtClean="0"/>
+              <a:t>Third level</a:t>
+            </a:r>
+          </a:p>
+          <a:p>
+            <a:pPr lvl="3"/>
+            <a:r>
+              <a:rPr lang="en-US" smtClean="0"/>
+              <a:t>Fourth level</a:t>
+            </a:r>
+          </a:p>
+          <a:p>
+            <a:pPr lvl="4"/>
+            <a:r>
+              <a:rPr lang="en-US" smtClean="0"/>
+              <a:t>Fifth level</a:t>
+            </a:r>
+            <a:endParaRPr lang="en-US"/>
+          </a:p>
+        </p:txBody>
+      </p:sp>
+      <p:sp>
+        <p:nvSpPr>
+          <p:cNvPr id="6" name="Footer Placeholder 5"/>
+          <p:cNvSpPr>
+            <a:spLocks noGrp="1"/>
+          </p:cNvSpPr>
+          <p:nvPr>
+            <p:ph type="ftr" sz="quarter" idx="4"/>
+          </p:nvPr>
+        </p:nvSpPr>
+        <p:spPr>
+          <a:xfrm>
+            <a:off x="0" y="8685213"/>
+            <a:ext cx="2971800" cy="457200"/>
+          </a:xfrm>
+          <a:prstGeom prst="rect">
+            <a:avLst/>
+          </a:prstGeom>
+        </p:spPr>
+        <p:txBody>
+          <a:bodyPr vert="horz" lIns="91440" tIns="45720" rIns="91440" bIns="45720" rtlCol="0" anchor="b"/>
+          <a:lstStyle>
+            <a:lvl1pPr algn="l">
+              <a:defRPr sz="1200"/>
+            </a:lvl1pPr>
+          </a:lstStyle>
+          <a:p>
+            <a:endParaRPr lang="en-US"/>
+          </a:p>
+        </p:txBody>
+      </p:sp>
+      <p:sp>
+        <p:nvSpPr>
+          <p:cNvPr id="7" name="Slide Number Placeholder 6"/>
+          <p:cNvSpPr>
+            <a:spLocks noGrp="1"/>
+          </p:cNvSpPr>
+          <p:nvPr>
+            <p:ph type="sldNum" sz="quarter" idx="5"/>
+          </p:nvPr>
+        </p:nvSpPr>
+        <p:spPr>
+          <a:xfrm>
+            <a:off x="3884613" y="8685213"/>
+            <a:ext cx="2971800" cy="457200"/>
+          </a:xfrm>
+          <a:prstGeom prst="rect">
+            <a:avLst/>
+          </a:prstGeom>
+        </p:spPr>
+        <p:txBody>
+          <a:bodyPr vert="horz" lIns="91440" tIns="45720" rIns="91440" bIns="45720" rtlCol="0" anchor="b"/>
+          <a:lstStyle>
+            <a:lvl1pPr algn="r">
+              <a:defRPr sz="1200"/>
+            </a:lvl1pPr>
+          </a:lstStyle>
+          <a:p>
+            <a:fld id="{BB5E49A5-4136-284D-997B-48E1D791AD67}" type="slidenum">
+              <a:rPr lang="en-US" smtClean="0"/>
+              <a:t>‹#›</a:t>
+            </a:fld>
+            <a:endParaRPr lang="en-US"/>
+          </a:p>
+        </p:txBody>
+      </p:sp>
+    </p:spTree>
+    <p:extLst>
+      <p:ext uri="{BB962C8B-B14F-4D97-AF65-F5344CB8AC3E}">
+        <p14:creationId xmlns:p14="http://schemas.microsoft.com/office/powerpoint/2010/main" val="2623252185"/>
+      </p:ext>
+    </p:extLst>
+  </p:cSld>
+  <p:clrMap bg1="lt1" tx1="dk1" bg2="lt2" tx2="dk2" accent1="accent1" accent2="accent2" accent3="accent3" accent4="accent4" accent5="accent5" accent6="accent6" hlink="hlink" folHlink="folHlink"/>
+  <p:notesStyle>
+    <a:lvl1pPr marL="0" algn="l" defTabSz="457200" rtl="0" eaLnBrk="1" latinLnBrk="0" hangingPunct="1">
+      <a:defRPr sz="1200" kern="1200">
+        <a:solidFill>
+          <a:schemeClr val="tx1"/>
+        </a:solidFill>
+        <a:latin typeface="+mn-lt"/>
+        <a:ea typeface="+mn-ea"/>
+        <a:cs typeface="+mn-cs"/>
+      </a:defRPr>
+    </a:lvl1pPr>
+    <a:lvl2pPr marL="457200" algn="l" defTabSz="457200" rtl="0" eaLnBrk="1" latinLnBrk="0" hangingPunct="1">
+      <a:defRPr sz="1200" kern="1200">
+        <a:solidFill>
+          <a:schemeClr val="tx1"/>
+        </a:solidFill>
+        <a:latin typeface="+mn-lt"/>
+        <a:ea typeface="+mn-ea"/>
+        <a:cs typeface="+mn-cs"/>
+      </a:defRPr>
+    </a:lvl2pPr>
+    <a:lvl3pPr marL="914400" algn="l" defTabSz="457200" rtl="0" eaLnBrk="1" latinLnBrk="0" hangingPunct="1">
+      <a:defRPr sz="1200" kern="1200">
+        <a:solidFill>
+          <a:schemeClr val="tx1"/>
+        </a:solidFill>
+        <a:latin typeface="+mn-lt"/>
+        <a:ea typeface="+mn-ea"/>
+        <a:cs typeface="+mn-cs"/>
+      </a:defRPr>
+    </a:lvl3pPr>
+    <a:lvl4pPr marL="1371600" algn="l" defTabSz="457200" rtl="0" eaLnBrk="1" latinLnBrk="0" hangingPunct="1">
+      <a:defRPr sz="1200" kern="1200">
+        <a:solidFill>
+          <a:schemeClr val="tx1"/>
+        </a:solidFill>
+        <a:latin typeface="+mn-lt"/>
+        <a:ea typeface="+mn-ea"/>
+        <a:cs typeface="+mn-cs"/>
+      </a:defRPr>
+    </a:lvl4pPr>
+    <a:lvl5pPr marL="1828800" algn="l" defTabSz="457200" rtl="0" eaLnBrk="1" latinLnBrk="0" hangingPunct="1">
+      <a:defRPr sz="1200" kern="1200">
+        <a:solidFill>
+          <a:schemeClr val="tx1"/>
+        </a:solidFill>
+        <a:latin typeface="+mn-lt"/>
+        <a:ea typeface="+mn-ea"/>
+        <a:cs typeface="+mn-cs"/>
+      </a:defRPr>
+    </a:lvl5pPr>
+    <a:lvl6pPr marL="2286000" algn="l" defTabSz="457200" rtl="0" eaLnBrk="1" latinLnBrk="0" hangingPunct="1">
+      <a:defRPr sz="1200" kern="1200">
+        <a:solidFill>
+          <a:schemeClr val="tx1"/>
+        </a:solidFill>
+        <a:latin typeface="+mn-lt"/>
+        <a:ea typeface="+mn-ea"/>
+        <a:cs typeface="+mn-cs"/>
+      </a:defRPr>
+    </a:lvl6pPr>
+    <a:lvl7pPr marL="2743200" algn="l" defTabSz="457200" rtl="0" eaLnBrk="1" latinLnBrk="0" hangingPunct="1">
+      <a:defRPr sz="1200" kern="1200">
+        <a:solidFill>
+          <a:schemeClr val="tx1"/>
+        </a:solidFill>
+        <a:latin typeface="+mn-lt"/>
+        <a:ea typeface="+mn-ea"/>
+        <a:cs typeface="+mn-cs"/>
+      </a:defRPr>
+    </a:lvl7pPr>
+    <a:lvl8pPr marL="3200400" algn="l" defTabSz="457200" rtl="0" eaLnBrk="1" latinLnBrk="0" hangingPunct="1">
+      <a:defRPr sz="1200" kern="1200">
+        <a:solidFill>
+          <a:schemeClr val="tx1"/>
+        </a:solidFill>
+        <a:latin typeface="+mn-lt"/>
+        <a:ea typeface="+mn-ea"/>
+        <a:cs typeface="+mn-cs"/>
+      </a:defRPr>
+    </a:lvl8pPr>
+    <a:lvl9pPr marL="3657600" algn="l" defTabSz="457200" rtl="0" eaLnBrk="1" latinLnBrk="0" hangingPunct="1">
+      <a:defRPr sz="1200" kern="1200">
+        <a:solidFill>
+          <a:schemeClr val="tx1"/>
+        </a:solidFill>
+        <a:latin typeface="+mn-lt"/>
+        <a:ea typeface="+mn-ea"/>
+        <a:cs typeface="+mn-cs"/>
+      </a:defRPr>
+    </a:lvl9pPr>
+  </p:notesStyle>
+</p:notesMaster>
+</file>
+
+<file path=ppt/notesSlides/notesSlide1.xml><?xml version="1.0" encoding="utf-8"?>
+<p:notes xmlns:a="http://schemas.openxmlformats.org/drawingml/2006/main" xmlns:p="http://schemas.openxmlformats.org/presentationml/2006/main" xmlns:r="http://schemas.openxmlformats.org/officeDocument/2006/relationships">
+  <p:cSld>
+    <p:spTree>
+      <p:nvGrpSpPr>
+        <p:cNvPr id="1" name=""/>
+        <p:cNvGrpSpPr/>
+        <p:nvPr/>
+      </p:nvGrpSpPr>
+      <p:grpSpPr>
+        <a:xfrm>
+          <a:off x="0" y="0"/>
+          <a:ext cx="0" cy="0"/>
+          <a:chOff x="0" y="0"/>
+          <a:chExt cx="0" cy="0"/>
+        </a:xfrm>
+      </p:grpSpPr>
+      <p:sp>
+        <p:nvSpPr>
+          <p:cNvPr id="2" name="Slide Image Placeholder 1"/>
+          <p:cNvSpPr>
+            <a:spLocks noGrp="1"/>
+          </p:cNvSpPr>
+          <p:nvPr>
+            <p:ph type="sldImg" idx="2"/>
+          </p:nvPr>
+        </p:nvSpPr>
+        <p:spPr/>
+      </p:sp>
+      <p:sp>
+        <p:nvSpPr>
+          <p:cNvPr id="3" name="Notes Placeholder 2"/>
+          <p:cNvSpPr>
+            <a:spLocks noGrp="1"/>
+          </p:cNvSpPr>
+          <p:nvPr>
+            <p:ph type="body" idx="3" sz="quarter"/>
+          </p:nvPr>
+        </p:nvSpPr>
+        <p:spPr/>
+        <p:txBody>
+          <a:bodyPr/>
+          <a:lstStyle/>
+          <a:p>
+            <a:r>
+              <a:t>Hi everyone, I am Srikar. Today I will walk us through the GraphJudge paper that Professor Tao and Sumanth shared with us, since we will be implementing it for KGCompass. Quick credibility note: this was accepted at EMNLP 2025 main conference, and the authors released both their code and their trained model weights, which helps us a lot.</a:t>
+            </a:r>
+          </a:p>
+        </p:txBody>
+      </p:sp>
+      <p:sp>
+        <p:nvSpPr>
+          <p:cNvPr id="4" name="Slide Number Placeholder 3"/>
+          <p:cNvSpPr>
+            <a:spLocks noGrp="1"/>
+          </p:cNvSpPr>
+          <p:nvPr>
+            <p:ph type="sldNum" idx="5" sz="quarter"/>
+          </p:nvPr>
+        </p:nvSpPr>
+        <p:spPr/>
+      </p:sp>
+    </p:spTree>
+  </p:cSld>
+  <p:clrMapOvr>
+    <a:masterClrMapping/>
+  </p:clrMapOvr>
+</p:notes>
+</file>
+
+<file path=ppt/notesSlides/notesSlide10.xml><?xml version="1.0" encoding="utf-8"?>
+<p:notes xmlns:a="http://schemas.openxmlformats.org/drawingml/2006/main" xmlns:p="http://schemas.openxmlformats.org/presentationml/2006/main" xmlns:r="http://schemas.openxmlformats.org/officeDocument/2006/relationships">
+  <p:cSld>
+    <p:spTree>
+      <p:nvGrpSpPr>
+        <p:cNvPr id="1" name=""/>
+        <p:cNvGrpSpPr/>
+        <p:nvPr/>
+      </p:nvGrpSpPr>
+      <p:grpSpPr>
+        <a:xfrm>
+          <a:off x="0" y="0"/>
+          <a:ext cx="0" cy="0"/>
+          <a:chOff x="0" y="0"/>
+          <a:chExt cx="0" cy="0"/>
+        </a:xfrm>
+      </p:grpSpPr>
+      <p:sp>
+        <p:nvSpPr>
+          <p:cNvPr id="2" name="Slide Image Placeholder 1"/>
+          <p:cNvSpPr>
+            <a:spLocks noGrp="1"/>
+          </p:cNvSpPr>
+          <p:nvPr>
+            <p:ph type="sldImg" idx="2"/>
+          </p:nvPr>
+        </p:nvSpPr>
+        <p:spPr/>
+      </p:sp>
+      <p:sp>
+        <p:nvSpPr>
+          <p:cNvPr id="3" name="Notes Placeholder 2"/>
+          <p:cNvSpPr>
+            <a:spLocks noGrp="1"/>
+          </p:cNvSpPr>
+          <p:nvPr>
+            <p:ph type="body" idx="3" sz="quarter"/>
+          </p:nvPr>
+        </p:nvSpPr>
+        <p:spPr/>
+        <p:txBody>
+          <a:bodyPr/>
+          <a:lstStyle/>
+          <a:p>
+            <a:r>
+              <a:t>This is our own hands-on work from this week, not the paper. I cloned the official repo, fixed a small device bug for Mac, ran an extraction pass on 15 SCIERC abstracts, then a strict filtering pass, and scored both with the paper's own metric code. Filtering raised precision on every metric, that is the graph judge effect reproduced. But my crude filter also deleted correct triples so recall fell. That is exactly why they fine-tune a judge instead of using rules. Sumanth is leading the triplet accuracy checking that Professor Tao assigned, and this experiment supports that direction directly.</a:t>
+            </a:r>
+          </a:p>
+        </p:txBody>
+      </p:sp>
+      <p:sp>
+        <p:nvSpPr>
+          <p:cNvPr id="4" name="Slide Number Placeholder 3"/>
+          <p:cNvSpPr>
+            <a:spLocks noGrp="1"/>
+          </p:cNvSpPr>
+          <p:nvPr>
+            <p:ph type="sldNum" idx="5" sz="quarter"/>
+          </p:nvPr>
+        </p:nvSpPr>
+        <p:spPr/>
+      </p:sp>
+    </p:spTree>
+  </p:cSld>
+  <p:clrMapOvr>
+    <a:masterClrMapping/>
+  </p:clrMapOvr>
+</p:notes>
+</file>
+
+<file path=ppt/notesSlides/notesSlide11.xml><?xml version="1.0" encoding="utf-8"?>
+<p:notes xmlns:a="http://schemas.openxmlformats.org/drawingml/2006/main" xmlns:p="http://schemas.openxmlformats.org/presentationml/2006/main" xmlns:r="http://schemas.openxmlformats.org/officeDocument/2006/relationships">
+  <p:cSld>
+    <p:spTree>
+      <p:nvGrpSpPr>
+        <p:cNvPr id="1" name=""/>
+        <p:cNvGrpSpPr/>
+        <p:nvPr/>
+      </p:nvGrpSpPr>
+      <p:grpSpPr>
+        <a:xfrm>
+          <a:off x="0" y="0"/>
+          <a:ext cx="0" cy="0"/>
+          <a:chOff x="0" y="0"/>
+          <a:chExt cx="0" cy="0"/>
+        </a:xfrm>
+      </p:grpSpPr>
+      <p:sp>
+        <p:nvSpPr>
+          <p:cNvPr id="2" name="Slide Image Placeholder 1"/>
+          <p:cNvSpPr>
+            <a:spLocks noGrp="1"/>
+          </p:cNvSpPr>
+          <p:nvPr>
+            <p:ph type="sldImg" idx="2"/>
+          </p:nvPr>
+        </p:nvSpPr>
+        <p:spPr/>
+      </p:sp>
+      <p:sp>
+        <p:nvSpPr>
+          <p:cNvPr id="3" name="Notes Placeholder 2"/>
+          <p:cNvSpPr>
+            <a:spLocks noGrp="1"/>
+          </p:cNvSpPr>
+          <p:nvPr>
+            <p:ph type="body" idx="3" sz="quarter"/>
+          </p:nvPr>
+        </p:nvSpPr>
+        <p:spPr/>
+        <p:txBody>
+          <a:bodyPr/>
+          <a:lstStyle/>
+          <a:p>
+            <a:r>
+              <a:t>Mapping to our project. From what Sumanth explained to me about the KGCompass plan: the capstone side builds the animal science KG, and the directed studies side produces the research, evaluating construction approaches and pruning. GraphJudge gives us the recipe: over-generate, judge, filter. The gold set we label as a team does double duty, judge training data and evaluation standard. And the released weights mean we can demo a judge before training anything.</a:t>
+            </a:r>
+          </a:p>
+        </p:txBody>
+      </p:sp>
+      <p:sp>
+        <p:nvSpPr>
+          <p:cNvPr id="4" name="Slide Number Placeholder 3"/>
+          <p:cNvSpPr>
+            <a:spLocks noGrp="1"/>
+          </p:cNvSpPr>
+          <p:nvPr>
+            <p:ph type="sldNum" idx="5" sz="quarter"/>
+          </p:nvPr>
+        </p:nvSpPr>
+        <p:spPr/>
+      </p:sp>
+    </p:spTree>
+  </p:cSld>
+  <p:clrMapOvr>
+    <a:masterClrMapping/>
+  </p:clrMapOvr>
+</p:notes>
+</file>
+
+<file path=ppt/notesSlides/notesSlide12.xml><?xml version="1.0" encoding="utf-8"?>
+<p:notes xmlns:a="http://schemas.openxmlformats.org/drawingml/2006/main" xmlns:p="http://schemas.openxmlformats.org/presentationml/2006/main" xmlns:r="http://schemas.openxmlformats.org/officeDocument/2006/relationships">
+  <p:cSld>
+    <p:spTree>
+      <p:nvGrpSpPr>
+        <p:cNvPr id="1" name=""/>
+        <p:cNvGrpSpPr/>
+        <p:nvPr/>
+      </p:nvGrpSpPr>
+      <p:grpSpPr>
+        <a:xfrm>
+          <a:off x="0" y="0"/>
+          <a:ext cx="0" cy="0"/>
+          <a:chOff x="0" y="0"/>
+          <a:chExt cx="0" cy="0"/>
+        </a:xfrm>
+      </p:grpSpPr>
+      <p:sp>
+        <p:nvSpPr>
+          <p:cNvPr id="2" name="Slide Image Placeholder 1"/>
+          <p:cNvSpPr>
+            <a:spLocks noGrp="1"/>
+          </p:cNvSpPr>
+          <p:nvPr>
+            <p:ph type="sldImg" idx="2"/>
+          </p:nvPr>
+        </p:nvSpPr>
+        <p:spPr/>
+      </p:sp>
+      <p:sp>
+        <p:nvSpPr>
+          <p:cNvPr id="3" name="Notes Placeholder 2"/>
+          <p:cNvSpPr>
+            <a:spLocks noGrp="1"/>
+          </p:cNvSpPr>
+          <p:nvPr>
+            <p:ph type="body" idx="3" sz="quarter"/>
+          </p:nvPr>
+        </p:nvSpPr>
+        <p:spPr/>
+        <p:txBody>
+          <a:bodyPr/>
+          <a:lstStyle/>
+          <a:p>
+            <a:r>
+              <a:t>Reading critically, the authors admit three limitations, and each one is a paper opportunity for us: richer knowledge units beyond flat triples, evaluation without gold graphs, and the judge being weaker on specialized text, SCIERC 0.63 versus 0.92 on general text, which says domain gold data matters. Sumanth also mentioned the pruning idea, removing low value nodes to improve accuracy, which fits here as the post-construction complement to judge filtering.</a:t>
+            </a:r>
+          </a:p>
+        </p:txBody>
+      </p:sp>
+      <p:sp>
+        <p:nvSpPr>
+          <p:cNvPr id="4" name="Slide Number Placeholder 3"/>
+          <p:cNvSpPr>
+            <a:spLocks noGrp="1"/>
+          </p:cNvSpPr>
+          <p:nvPr>
+            <p:ph type="sldNum" idx="5" sz="quarter"/>
+          </p:nvPr>
+        </p:nvSpPr>
+        <p:spPr/>
+      </p:sp>
+    </p:spTree>
+  </p:cSld>
+  <p:clrMapOvr>
+    <a:masterClrMapping/>
+  </p:clrMapOvr>
+</p:notes>
+</file>
+
+<file path=ppt/notesSlides/notesSlide13.xml><?xml version="1.0" encoding="utf-8"?>
+<p:notes xmlns:a="http://schemas.openxmlformats.org/drawingml/2006/main" xmlns:p="http://schemas.openxmlformats.org/presentationml/2006/main" xmlns:r="http://schemas.openxmlformats.org/officeDocument/2006/relationships">
+  <p:cSld>
+    <p:spTree>
+      <p:nvGrpSpPr>
+        <p:cNvPr id="1" name=""/>
+        <p:cNvGrpSpPr/>
+        <p:nvPr/>
+      </p:nvGrpSpPr>
+      <p:grpSpPr>
+        <a:xfrm>
+          <a:off x="0" y="0"/>
+          <a:ext cx="0" cy="0"/>
+          <a:chOff x="0" y="0"/>
+          <a:chExt cx="0" cy="0"/>
+        </a:xfrm>
+      </p:grpSpPr>
+      <p:sp>
+        <p:nvSpPr>
+          <p:cNvPr id="2" name="Slide Image Placeholder 1"/>
+          <p:cNvSpPr>
+            <a:spLocks noGrp="1"/>
+          </p:cNvSpPr>
+          <p:nvPr>
+            <p:ph type="sldImg" idx="2"/>
+          </p:nvPr>
+        </p:nvSpPr>
+        <p:spPr/>
+      </p:sp>
+      <p:sp>
+        <p:nvSpPr>
+          <p:cNvPr id="3" name="Notes Placeholder 2"/>
+          <p:cNvSpPr>
+            <a:spLocks noGrp="1"/>
+          </p:cNvSpPr>
+          <p:nvPr>
+            <p:ph type="body" idx="3" sz="quarter"/>
+          </p:nvPr>
+        </p:nvSpPr>
+        <p:spPr/>
+        <p:txBody>
+          <a:bodyPr/>
+          <a:lstStyle/>
+          <a:p>
+            <a:r>
+              <a:t>Proposed two month plan. Weeks one and two, full SCIERC reproduction with the released judge weights and HPRC set up. Weeks three and four, assemble the animal science corpus, I understood from Sumanth that Dr. Kaniyamattam will guide the corpus side, and run ECTD over it. Weeks five and six, team labeling sprint and fine-tune the domain judge. Weeks seven and eight, filter the full KG, measure against the gold set, and first pruning experiments. Happy to adjust this with everyone's availability.</a:t>
+            </a:r>
+          </a:p>
+        </p:txBody>
+      </p:sp>
+      <p:sp>
+        <p:nvSpPr>
+          <p:cNvPr id="4" name="Slide Number Placeholder 3"/>
+          <p:cNvSpPr>
+            <a:spLocks noGrp="1"/>
+          </p:cNvSpPr>
+          <p:nvPr>
+            <p:ph type="sldNum" idx="5" sz="quarter"/>
+          </p:nvPr>
+        </p:nvSpPr>
+        <p:spPr/>
+      </p:sp>
+    </p:spTree>
+  </p:cSld>
+  <p:clrMapOvr>
+    <a:masterClrMapping/>
+  </p:clrMapOvr>
+</p:notes>
+</file>
+
+<file path=ppt/notesSlides/notesSlide2.xml><?xml version="1.0" encoding="utf-8"?>
+<p:notes xmlns:a="http://schemas.openxmlformats.org/drawingml/2006/main" xmlns:p="http://schemas.openxmlformats.org/presentationml/2006/main" xmlns:r="http://schemas.openxmlformats.org/officeDocument/2006/relationships">
+  <p:cSld>
+    <p:spTree>
+      <p:nvGrpSpPr>
+        <p:cNvPr id="1" name=""/>
+        <p:cNvGrpSpPr/>
+        <p:nvPr/>
+      </p:nvGrpSpPr>
+      <p:grpSpPr>
+        <a:xfrm>
+          <a:off x="0" y="0"/>
+          <a:ext cx="0" cy="0"/>
+          <a:chOff x="0" y="0"/>
+          <a:chExt cx="0" cy="0"/>
+        </a:xfrm>
+      </p:grpSpPr>
+      <p:sp>
+        <p:nvSpPr>
+          <p:cNvPr id="2" name="Slide Image Placeholder 1"/>
+          <p:cNvSpPr>
+            <a:spLocks noGrp="1"/>
+          </p:cNvSpPr>
+          <p:nvPr>
+            <p:ph type="sldImg" idx="2"/>
+          </p:nvPr>
+        </p:nvSpPr>
+        <p:spPr/>
+      </p:sp>
+      <p:sp>
+        <p:nvSpPr>
+          <p:cNvPr id="3" name="Notes Placeholder 2"/>
+          <p:cNvSpPr>
+            <a:spLocks noGrp="1"/>
+          </p:cNvSpPr>
+          <p:nvPr>
+            <p:ph type="body" idx="3" sz="quarter"/>
+          </p:nvPr>
+        </p:nvSpPr>
+        <p:spPr/>
+        <p:txBody>
+          <a:bodyPr/>
+          <a:lstStyle/>
+          <a:p>
+            <a:r>
+              <a:t>Before the paper itself, why do we care. I got this framing from Sumanth: our end goal is a GraphRAG system, and as Professor Tao said, before we use a KG for GraphRAG we need the triplets to be as close to 100 percent accurate as possible. One wrong triple can poison every answer built on top of it. The examples on the right show what triples look like, including a real failure where an LLM extracted an advertisement as a medical fact.</a:t>
+            </a:r>
+          </a:p>
+        </p:txBody>
+      </p:sp>
+      <p:sp>
+        <p:nvSpPr>
+          <p:cNvPr id="4" name="Slide Number Placeholder 3"/>
+          <p:cNvSpPr>
+            <a:spLocks noGrp="1"/>
+          </p:cNvSpPr>
+          <p:nvPr>
+            <p:ph type="sldNum" idx="5" sz="quarter"/>
+          </p:nvPr>
+        </p:nvSpPr>
+        <p:spPr/>
+      </p:sp>
+    </p:spTree>
+  </p:cSld>
+  <p:clrMapOvr>
+    <a:masterClrMapping/>
+  </p:clrMapOvr>
+</p:notes>
+</file>
+
+<file path=ppt/notesSlides/notesSlide3.xml><?xml version="1.0" encoding="utf-8"?>
+<p:notes xmlns:a="http://schemas.openxmlformats.org/drawingml/2006/main" xmlns:p="http://schemas.openxmlformats.org/presentationml/2006/main" xmlns:r="http://schemas.openxmlformats.org/officeDocument/2006/relationships">
+  <p:cSld>
+    <p:spTree>
+      <p:nvGrpSpPr>
+        <p:cNvPr id="1" name=""/>
+        <p:cNvGrpSpPr/>
+        <p:nvPr/>
+      </p:nvGrpSpPr>
+      <p:grpSpPr>
+        <a:xfrm>
+          <a:off x="0" y="0"/>
+          <a:ext cx="0" cy="0"/>
+          <a:chOff x="0" y="0"/>
+          <a:chExt cx="0" cy="0"/>
+        </a:xfrm>
+      </p:grpSpPr>
+      <p:sp>
+        <p:nvSpPr>
+          <p:cNvPr id="2" name="Slide Image Placeholder 1"/>
+          <p:cNvSpPr>
+            <a:spLocks noGrp="1"/>
+          </p:cNvSpPr>
+          <p:nvPr>
+            <p:ph type="sldImg" idx="2"/>
+          </p:nvPr>
+        </p:nvSpPr>
+        <p:spPr/>
+      </p:sp>
+      <p:sp>
+        <p:nvSpPr>
+          <p:cNvPr id="3" name="Notes Placeholder 2"/>
+          <p:cNvSpPr>
+            <a:spLocks noGrp="1"/>
+          </p:cNvSpPr>
+          <p:nvPr>
+            <p:ph type="body" idx="3" sz="quarter"/>
+          </p:nvPr>
+        </p:nvSpPr>
+        <p:spPr/>
+        <p:txBody>
+          <a:bodyPr/>
+          <a:lstStyle/>
+          <a:p>
+            <a:r>
+              <a:t>Three failure modes when you naively ask an LLM to extract triples. One, noise: real documents have ads and boilerplate and the model extracts them. Two, missing domain knowledge: the text says linked to better outcomes and the model writes cured. Three, hallucination: triples invented from nothing. Note all three are precision failures, which is exactly why Professor Tao asked Sumanth to start with checking triplet accuracy first.</a:t>
+            </a:r>
+          </a:p>
+        </p:txBody>
+      </p:sp>
+      <p:sp>
+        <p:nvSpPr>
+          <p:cNvPr id="4" name="Slide Number Placeholder 3"/>
+          <p:cNvSpPr>
+            <a:spLocks noGrp="1"/>
+          </p:cNvSpPr>
+          <p:nvPr>
+            <p:ph type="sldNum" idx="5" sz="quarter"/>
+          </p:nvPr>
+        </p:nvSpPr>
+        <p:spPr/>
+      </p:sp>
+    </p:spTree>
+  </p:cSld>
+  <p:clrMapOvr>
+    <a:masterClrMapping/>
+  </p:clrMapOvr>
+</p:notes>
+</file>
+
+<file path=ppt/notesSlides/notesSlide4.xml><?xml version="1.0" encoding="utf-8"?>
+<p:notes xmlns:a="http://schemas.openxmlformats.org/drawingml/2006/main" xmlns:p="http://schemas.openxmlformats.org/presentationml/2006/main" xmlns:r="http://schemas.openxmlformats.org/officeDocument/2006/relationships">
+  <p:cSld>
+    <p:spTree>
+      <p:nvGrpSpPr>
+        <p:cNvPr id="1" name=""/>
+        <p:cNvGrpSpPr/>
+        <p:nvPr/>
+      </p:nvGrpSpPr>
+      <p:grpSpPr>
+        <a:xfrm>
+          <a:off x="0" y="0"/>
+          <a:ext cx="0" cy="0"/>
+          <a:chOff x="0" y="0"/>
+          <a:chExt cx="0" cy="0"/>
+        </a:xfrm>
+      </p:grpSpPr>
+      <p:sp>
+        <p:nvSpPr>
+          <p:cNvPr id="2" name="Slide Image Placeholder 1"/>
+          <p:cNvSpPr>
+            <a:spLocks noGrp="1"/>
+          </p:cNvSpPr>
+          <p:nvPr>
+            <p:ph type="sldImg" idx="2"/>
+          </p:nvPr>
+        </p:nvSpPr>
+        <p:spPr/>
+      </p:sp>
+      <p:sp>
+        <p:nvSpPr>
+          <p:cNvPr id="3" name="Notes Placeholder 2"/>
+          <p:cNvSpPr>
+            <a:spLocks noGrp="1"/>
+          </p:cNvSpPr>
+          <p:nvPr>
+            <p:ph type="body" idx="3" sz="quarter"/>
+          </p:nvPr>
+        </p:nvSpPr>
+        <p:spPr/>
+        <p:txBody>
+          <a:bodyPr/>
+          <a:lstStyle/>
+          <a:p>
+            <a:r>
+              <a:t>The core idea of the paper in one line: use two models with different jobs. A big closed model over-generates candidate triples so we do not miss facts, recall. Then a small open model, fine-tuned for exactly one question, is this triple true given this document, filters them, precision. The surprising result: the little fine-tuned 7B judge is over 90 percent accurate at judging, better than GPT-4o itself at that narrow task.</a:t>
+            </a:r>
+          </a:p>
+        </p:txBody>
+      </p:sp>
+      <p:sp>
+        <p:nvSpPr>
+          <p:cNvPr id="4" name="Slide Number Placeholder 3"/>
+          <p:cNvSpPr>
+            <a:spLocks noGrp="1"/>
+          </p:cNvSpPr>
+          <p:nvPr>
+            <p:ph type="sldNum" idx="5" sz="quarter"/>
+          </p:nvPr>
+        </p:nvSpPr>
+        <p:spPr/>
+      </p:sp>
+    </p:spTree>
+  </p:cSld>
+  <p:clrMapOvr>
+    <a:masterClrMapping/>
+  </p:clrMapOvr>
+</p:notes>
+</file>
+
+<file path=ppt/notesSlides/notesSlide5.xml><?xml version="1.0" encoding="utf-8"?>
+<p:notes xmlns:a="http://schemas.openxmlformats.org/drawingml/2006/main" xmlns:p="http://schemas.openxmlformats.org/presentationml/2006/main" xmlns:r="http://schemas.openxmlformats.org/officeDocument/2006/relationships">
+  <p:cSld>
+    <p:spTree>
+      <p:nvGrpSpPr>
+        <p:cNvPr id="1" name=""/>
+        <p:cNvGrpSpPr/>
+        <p:nvPr/>
+      </p:nvGrpSpPr>
+      <p:grpSpPr>
+        <a:xfrm>
+          <a:off x="0" y="0"/>
+          <a:ext cx="0" cy="0"/>
+          <a:chOff x="0" y="0"/>
+          <a:chExt cx="0" cy="0"/>
+        </a:xfrm>
+      </p:grpSpPr>
+      <p:sp>
+        <p:nvSpPr>
+          <p:cNvPr id="2" name="Slide Image Placeholder 1"/>
+          <p:cNvSpPr>
+            <a:spLocks noGrp="1"/>
+          </p:cNvSpPr>
+          <p:nvPr>
+            <p:ph type="sldImg" idx="2"/>
+          </p:nvPr>
+        </p:nvSpPr>
+        <p:spPr/>
+      </p:sp>
+      <p:sp>
+        <p:nvSpPr>
+          <p:cNvPr id="3" name="Notes Placeholder 2"/>
+          <p:cNvSpPr>
+            <a:spLocks noGrp="1"/>
+          </p:cNvSpPr>
+          <p:nvPr>
+            <p:ph type="body" idx="3" sz="quarter"/>
+          </p:nvPr>
+        </p:nvSpPr>
+        <p:spPr/>
+        <p:txBody>
+          <a:bodyPr/>
+          <a:lstStyle/>
+          <a:p>
+            <a:r>
+              <a:t>The pipeline has three modules. ECTD cleans the document and over-extracts candidates. KASFT is where the judge is trained with LoRA. GJ is the filtering step. Important for us: the only training in the whole system is the small judge, and it runs on a single 48 GB GPU in 500 steps, so this fits TAMU HPRC easily.</a:t>
+            </a:r>
+          </a:p>
+        </p:txBody>
+      </p:sp>
+      <p:sp>
+        <p:nvSpPr>
+          <p:cNvPr id="4" name="Slide Number Placeholder 3"/>
+          <p:cNvSpPr>
+            <a:spLocks noGrp="1"/>
+          </p:cNvSpPr>
+          <p:nvPr>
+            <p:ph type="sldNum" idx="5" sz="quarter"/>
+          </p:nvPr>
+        </p:nvSpPr>
+        <p:spPr/>
+      </p:sp>
+    </p:spTree>
+  </p:cSld>
+  <p:clrMapOvr>
+    <a:masterClrMapping/>
+  </p:clrMapOvr>
+</p:notes>
+</file>
+
+<file path=ppt/notesSlides/notesSlide6.xml><?xml version="1.0" encoding="utf-8"?>
+<p:notes xmlns:a="http://schemas.openxmlformats.org/drawingml/2006/main" xmlns:p="http://schemas.openxmlformats.org/presentationml/2006/main" xmlns:r="http://schemas.openxmlformats.org/officeDocument/2006/relationships">
+  <p:cSld>
+    <p:spTree>
+      <p:nvGrpSpPr>
+        <p:cNvPr id="1" name=""/>
+        <p:cNvGrpSpPr/>
+        <p:nvPr/>
+      </p:nvGrpSpPr>
+      <p:grpSpPr>
+        <a:xfrm>
+          <a:off x="0" y="0"/>
+          <a:ext cx="0" cy="0"/>
+          <a:chOff x="0" y="0"/>
+          <a:chExt cx="0" cy="0"/>
+        </a:xfrm>
+      </p:grpSpPr>
+      <p:sp>
+        <p:nvSpPr>
+          <p:cNvPr id="2" name="Slide Image Placeholder 1"/>
+          <p:cNvSpPr>
+            <a:spLocks noGrp="1"/>
+          </p:cNvSpPr>
+          <p:nvPr>
+            <p:ph type="sldImg" idx="2"/>
+          </p:nvPr>
+        </p:nvSpPr>
+        <p:spPr/>
+      </p:sp>
+      <p:sp>
+        <p:nvSpPr>
+          <p:cNvPr id="3" name="Notes Placeholder 2"/>
+          <p:cNvSpPr>
+            <a:spLocks noGrp="1"/>
+          </p:cNvSpPr>
+          <p:nvPr>
+            <p:ph type="body" idx="3" sz="quarter"/>
+          </p:nvPr>
+        </p:nvSpPr>
+        <p:spPr/>
+        <p:txBody>
+          <a:bodyPr/>
+          <a:lstStyle/>
+          <a:p>
+            <a:r>
+              <a:t>Module one, ECTD. First the LLM lists the entities, then rewrites the document around those entities, which drops ads and noise. Then it extracts as many candidate triples as possible on purpose. The ablation shows why this matters: removing ECTD drops the score from 0.58 to 0.45 on REBEL. Garbage in, garbage out, even with a perfect judge.</a:t>
+            </a:r>
+          </a:p>
+        </p:txBody>
+      </p:sp>
+      <p:sp>
+        <p:nvSpPr>
+          <p:cNvPr id="4" name="Slide Number Placeholder 3"/>
+          <p:cNvSpPr>
+            <a:spLocks noGrp="1"/>
+          </p:cNvSpPr>
+          <p:nvPr>
+            <p:ph type="sldNum" idx="5" sz="quarter"/>
+          </p:nvPr>
+        </p:nvSpPr>
+        <p:spPr/>
+      </p:sp>
+    </p:spTree>
+  </p:cSld>
+  <p:clrMapOvr>
+    <a:masterClrMapping/>
+  </p:clrMapOvr>
+</p:notes>
+</file>
+
+<file path=ppt/notesSlides/notesSlide7.xml><?xml version="1.0" encoding="utf-8"?>
+<p:notes xmlns:a="http://schemas.openxmlformats.org/drawingml/2006/main" xmlns:p="http://schemas.openxmlformats.org/presentationml/2006/main" xmlns:r="http://schemas.openxmlformats.org/officeDocument/2006/relationships">
+  <p:cSld>
+    <p:spTree>
+      <p:nvGrpSpPr>
+        <p:cNvPr id="1" name=""/>
+        <p:cNvGrpSpPr/>
+        <p:nvPr/>
+      </p:nvGrpSpPr>
+      <p:grpSpPr>
+        <a:xfrm>
+          <a:off x="0" y="0"/>
+          <a:ext cx="0" cy="0"/>
+          <a:chOff x="0" y="0"/>
+          <a:chExt cx="0" cy="0"/>
+        </a:xfrm>
+      </p:grpSpPr>
+      <p:sp>
+        <p:nvSpPr>
+          <p:cNvPr id="2" name="Slide Image Placeholder 1"/>
+          <p:cNvSpPr>
+            <a:spLocks noGrp="1"/>
+          </p:cNvSpPr>
+          <p:nvPr>
+            <p:ph type="sldImg" idx="2"/>
+          </p:nvPr>
+        </p:nvSpPr>
+        <p:spPr/>
+      </p:sp>
+      <p:sp>
+        <p:nvSpPr>
+          <p:cNvPr id="3" name="Notes Placeholder 2"/>
+          <p:cNvSpPr>
+            <a:spLocks noGrp="1"/>
+          </p:cNvSpPr>
+          <p:nvPr>
+            <p:ph type="body" idx="3" sz="quarter"/>
+          </p:nvPr>
+        </p:nvSpPr>
+        <p:spPr/>
+        <p:txBody>
+          <a:bodyPr/>
+          <a:lstStyle/>
+          <a:p>
+            <a:r>
+              <a:t>Module two, how the judge is trained. Positives are real triples from gold graphs, negatives are the same triples with the tail entity swapped randomly. Each training example shows the document and asks yes or no about one triple. The prompt on the right is copied from the paper appendix, we can reuse it almost as is for animal science.</a:t>
+            </a:r>
+          </a:p>
+        </p:txBody>
+      </p:sp>
+      <p:sp>
+        <p:nvSpPr>
+          <p:cNvPr id="4" name="Slide Number Placeholder 3"/>
+          <p:cNvSpPr>
+            <a:spLocks noGrp="1"/>
+          </p:cNvSpPr>
+          <p:nvPr>
+            <p:ph type="sldNum" idx="5" sz="quarter"/>
+          </p:nvPr>
+        </p:nvSpPr>
+        <p:spPr/>
+      </p:sp>
+    </p:spTree>
+  </p:cSld>
+  <p:clrMapOvr>
+    <a:masterClrMapping/>
+  </p:clrMapOvr>
+</p:notes>
+</file>
+
+<file path=ppt/notesSlides/notesSlide8.xml><?xml version="1.0" encoding="utf-8"?>
+<p:notes xmlns:a="http://schemas.openxmlformats.org/drawingml/2006/main" xmlns:p="http://schemas.openxmlformats.org/presentationml/2006/main" xmlns:r="http://schemas.openxmlformats.org/officeDocument/2006/relationships">
+  <p:cSld>
+    <p:spTree>
+      <p:nvGrpSpPr>
+        <p:cNvPr id="1" name=""/>
+        <p:cNvGrpSpPr/>
+        <p:nvPr/>
+      </p:nvGrpSpPr>
+      <p:grpSpPr>
+        <a:xfrm>
+          <a:off x="0" y="0"/>
+          <a:ext cx="0" cy="0"/>
+          <a:chOff x="0" y="0"/>
+          <a:chExt cx="0" cy="0"/>
+        </a:xfrm>
+      </p:grpSpPr>
+      <p:sp>
+        <p:nvSpPr>
+          <p:cNvPr id="2" name="Slide Image Placeholder 1"/>
+          <p:cNvSpPr>
+            <a:spLocks noGrp="1"/>
+          </p:cNvSpPr>
+          <p:nvPr>
+            <p:ph type="sldImg" idx="2"/>
+          </p:nvPr>
+        </p:nvSpPr>
+        <p:spPr/>
+      </p:sp>
+      <p:sp>
+        <p:nvSpPr>
+          <p:cNvPr id="3" name="Notes Placeholder 2"/>
+          <p:cNvSpPr>
+            <a:spLocks noGrp="1"/>
+          </p:cNvSpPr>
+          <p:nvPr>
+            <p:ph type="body" idx="3" sz="quarter"/>
+          </p:nvPr>
+        </p:nvSpPr>
+        <p:spPr/>
+        <p:txBody>
+          <a:bodyPr/>
+          <a:lstStyle/>
+          <a:p>
+            <a:r>
+              <a:t>Results across four benchmarks, the metric is G-BERTScore F1, semantic matching. GraphJudge is best everywhere. Two takeaways worth saying out loud: a 7B judge beats PiVe which uses a 70B verifier, and it beats plain GPT-4o, so this is better AND much cheaper. Also the judge transfers across datasets, trained on one corpus it still helps on others.</a:t>
+            </a:r>
+          </a:p>
+        </p:txBody>
+      </p:sp>
+      <p:sp>
+        <p:nvSpPr>
+          <p:cNvPr id="4" name="Slide Number Placeholder 3"/>
+          <p:cNvSpPr>
+            <a:spLocks noGrp="1"/>
+          </p:cNvSpPr>
+          <p:nvPr>
+            <p:ph type="sldNum" idx="5" sz="quarter"/>
+          </p:nvPr>
+        </p:nvSpPr>
+        <p:spPr/>
+      </p:sp>
+    </p:spTree>
+  </p:cSld>
+  <p:clrMapOvr>
+    <a:masterClrMapping/>
+  </p:clrMapOvr>
+</p:notes>
+</file>
+
+<file path=ppt/notesSlides/notesSlide9.xml><?xml version="1.0" encoding="utf-8"?>
+<p:notes xmlns:a="http://schemas.openxmlformats.org/drawingml/2006/main" xmlns:p="http://schemas.openxmlformats.org/presentationml/2006/main" xmlns:r="http://schemas.openxmlformats.org/officeDocument/2006/relationships">
+  <p:cSld>
+    <p:spTree>
+      <p:nvGrpSpPr>
+        <p:cNvPr id="1" name=""/>
+        <p:cNvGrpSpPr/>
+        <p:nvPr/>
+      </p:nvGrpSpPr>
+      <p:grpSpPr>
+        <a:xfrm>
+          <a:off x="0" y="0"/>
+          <a:ext cx="0" cy="0"/>
+          <a:chOff x="0" y="0"/>
+          <a:chExt cx="0" cy="0"/>
+        </a:xfrm>
+      </p:grpSpPr>
+      <p:sp>
+        <p:nvSpPr>
+          <p:cNvPr id="2" name="Slide Image Placeholder 1"/>
+          <p:cNvSpPr>
+            <a:spLocks noGrp="1"/>
+          </p:cNvSpPr>
+          <p:nvPr>
+            <p:ph type="sldImg" idx="2"/>
+          </p:nvPr>
+        </p:nvSpPr>
+        <p:spPr/>
+      </p:sp>
+      <p:sp>
+        <p:nvSpPr>
+          <p:cNvPr id="3" name="Notes Placeholder 2"/>
+          <p:cNvSpPr>
+            <a:spLocks noGrp="1"/>
+          </p:cNvSpPr>
+          <p:nvPr>
+            <p:ph type="body" idx="3" sz="quarter"/>
+          </p:nvPr>
+        </p:nvSpPr>
+        <p:spPr/>
+        <p:txBody>
+          <a:bodyPr/>
+          <a:lstStyle/>
+          <a:p>
+            <a:r>
+              <a:t>This slide is about evaluation, which Professor Tao called the most challenging part. Exact string match is too harsh, part of versus component of should not count as wrong, so the field uses soft metrics, and G-BERTScore with embeddings is the headline one. The catch for us: every metric here needs a gold reference graph, and no gold KG exists for animal science. So one of our first team tasks is hand-building a small gold set. I would like the group's input on how we split that labeling work.</a:t>
+            </a:r>
+          </a:p>
+        </p:txBody>
+      </p:sp>
+      <p:sp>
+        <p:nvSpPr>
+          <p:cNvPr id="4" name="Slide Number Placeholder 3"/>
+          <p:cNvSpPr>
+            <a:spLocks noGrp="1"/>
+          </p:cNvSpPr>
+          <p:nvPr>
+            <p:ph type="sldNum" idx="5" sz="quarter"/>
+          </p:nvPr>
+        </p:nvSpPr>
+        <p:spPr/>
+      </p:sp>
+    </p:spTree>
+  </p:cSld>
+  <p:clrMapOvr>
+    <a:masterClrMapping/>
+  </p:clrMapOvr>
+</p:notes>
 </file>
 
 <file path=ppt/slideLayouts/slideLayout1.xml><?xml version="1.0" encoding="utf-8"?>
@@ -8278,4 +9538,324 @@
   </a:objectDefaults>
   <a:extraClrSchemeLst/>
 </a:theme>
+</file>
+
+<file path=ppt/theme/theme2.xml><?xml version="1.0" encoding="utf-8"?>
+<a:theme xmlns:a="http://schemas.openxmlformats.org/drawingml/2006/main" name="Office Theme">
+  <a:themeElements>
+    <a:clrScheme name="Office">
+      <a:dk1>
+        <a:sysClr val="windowText" lastClr="000000"/>
+      </a:dk1>
+      <a:lt1>
+        <a:sysClr val="window" lastClr="FFFFFF"/>
+      </a:lt1>
+      <a:dk2>
+        <a:srgbClr val="1F497D"/>
+      </a:dk2>
+      <a:lt2>
+        <a:srgbClr val="EEECE1"/>
+      </a:lt2>
+      <a:accent1>
+        <a:srgbClr val="4F81BD"/>
+      </a:accent1>
+      <a:accent2>
+        <a:srgbClr val="C0504D"/>
+      </a:accent2>
+      <a:accent3>
+        <a:srgbClr val="9BBB59"/>
+      </a:accent3>
+      <a:accent4>
+        <a:srgbClr val="8064A2"/>
+      </a:accent4>
+      <a:accent5>
+        <a:srgbClr val="4BACC6"/>
+      </a:accent5>
+      <a:accent6>
+        <a:srgbClr val="F79646"/>
+      </a:accent6>
+      <a:hlink>
+        <a:srgbClr val="0000FF"/>
+      </a:hlink>
+      <a:folHlink>
+        <a:srgbClr val="800080"/>
+      </a:folHlink>
+    </a:clrScheme>
+    <a:fontScheme name="Office">
+      <a:majorFont>
+        <a:latin typeface="Calibri"/>
+        <a:ea typeface=""/>
+        <a:cs typeface=""/>
+        <a:font script="Jpan" typeface="ＭＳ Ｐゴシック"/>
+        <a:font script="Hang" typeface="맑은 고딕"/>
+        <a:font script="Hans" typeface="宋体"/>
+        <a:font script="Hant" typeface="新細明體"/>
+        <a:font script="Arab" typeface="Times New Roman"/>
+        <a:font script="Hebr" typeface="Times New Roman"/>
+        <a:font script="Thai" typeface="Angsana New"/>
+        <a:font script="Ethi" typeface="Nyala"/>
+        <a:font script="Beng" typeface="Vrinda"/>
+        <a:font script="Gujr" typeface="Shruti"/>
+        <a:font script="Khmr" typeface="MoolBoran"/>
+        <a:font script="Knda" typeface="Tunga"/>
+        <a:font script="Guru" typeface="Raavi"/>
+        <a:font script="Cans" typeface="Euphemia"/>
+        <a:font script="Cher" typeface="Plantagenet Cherokee"/>
+        <a:font script="Yiii" typeface="Microsoft Yi Baiti"/>
+        <a:font script="Tibt" typeface="Microsoft Himalaya"/>
+        <a:font script="Thaa" typeface="MV Boli"/>
+        <a:font script="Deva" typeface="Mangal"/>
+        <a:font script="Telu" typeface="Gautami"/>
+        <a:font script="Taml" typeface="Latha"/>
+        <a:font script="Syrc" typeface="Estrangelo Edessa"/>
+        <a:font script="Orya" typeface="Kalinga"/>
+        <a:font script="Mlym" typeface="Kartika"/>
+        <a:font script="Laoo" typeface="DokChampa"/>
+        <a:font script="Sinh" typeface="Iskoola Pota"/>
+        <a:font script="Mong" typeface="Mongolian Baiti"/>
+        <a:font script="Viet" typeface="Times New Roman"/>
+        <a:font script="Uigh" typeface="Microsoft Uighur"/>
+        <a:font script="Geor" typeface="Sylfaen"/>
+      </a:majorFont>
+      <a:minorFont>
+        <a:latin typeface="Calibri"/>
+        <a:ea typeface=""/>
+        <a:cs typeface=""/>
+        <a:font script="Jpan" typeface="ＭＳ Ｐゴシック"/>
+        <a:font script="Hang" typeface="맑은 고딕"/>
+        <a:font script="Hans" typeface="宋体"/>
+        <a:font script="Hant" typeface="新細明體"/>
+        <a:font script="Arab" typeface="Arial"/>
+        <a:font script="Hebr" typeface="Arial"/>
+        <a:font script="Thai" typeface="Cordia New"/>
+        <a:font script="Ethi" typeface="Nyala"/>
+        <a:font script="Beng" typeface="Vrinda"/>
+        <a:font script="Gujr" typeface="Shruti"/>
+        <a:font script="Khmr" typeface="DaunPenh"/>
+        <a:font script="Knda" typeface="Tunga"/>
+        <a:font script="Guru" typeface="Raavi"/>
+        <a:font script="Cans" typeface="Euphemia"/>
+        <a:font script="Cher" typeface="Plantagenet Cherokee"/>
+        <a:font script="Yiii" typeface="Microsoft Yi Baiti"/>
+        <a:font script="Tibt" typeface="Microsoft Himalaya"/>
+        <a:font script="Thaa" typeface="MV Boli"/>
+        <a:font script="Deva" typeface="Mangal"/>
+        <a:font script="Telu" typeface="Gautami"/>
+        <a:font script="Taml" typeface="Latha"/>
+        <a:font script="Syrc" typeface="Estrangelo Edessa"/>
+        <a:font script="Orya" typeface="Kalinga"/>
+        <a:font script="Mlym" typeface="Kartika"/>
+        <a:font script="Laoo" typeface="DokChampa"/>
+        <a:font script="Sinh" typeface="Iskoola Pota"/>
+        <a:font script="Mong" typeface="Mongolian Baiti"/>
+        <a:font script="Viet" typeface="Arial"/>
+        <a:font script="Uigh" typeface="Microsoft Uighur"/>
+        <a:font script="Geor" typeface="Sylfaen"/>
+      </a:minorFont>
+    </a:fontScheme>
+    <a:fmtScheme name="Office">
+      <a:fillStyleLst>
+        <a:solidFill>
+          <a:schemeClr val="phClr"/>
+        </a:solidFill>
+        <a:gradFill rotWithShape="1">
+          <a:gsLst>
+            <a:gs pos="0">
+              <a:schemeClr val="phClr">
+                <a:tint val="50000"/>
+                <a:satMod val="300000"/>
+              </a:schemeClr>
+            </a:gs>
+            <a:gs pos="35000">
+              <a:schemeClr val="phClr">
+                <a:tint val="37000"/>
+                <a:satMod val="300000"/>
+              </a:schemeClr>
+            </a:gs>
+            <a:gs pos="100000">
+              <a:schemeClr val="phClr">
+                <a:tint val="15000"/>
+                <a:satMod val="350000"/>
+              </a:schemeClr>
+            </a:gs>
+          </a:gsLst>
+          <a:lin ang="16200000" scaled="1"/>
+        </a:gradFill>
+        <a:gradFill rotWithShape="1">
+          <a:gsLst>
+            <a:gs pos="0">
+              <a:schemeClr val="phClr">
+                <a:tint val="100000"/>
+                <a:shade val="100000"/>
+                <a:satMod val="130000"/>
+              </a:schemeClr>
+            </a:gs>
+            <a:gs pos="100000">
+              <a:schemeClr val="phClr">
+                <a:tint val="50000"/>
+                <a:shade val="100000"/>
+                <a:satMod val="350000"/>
+              </a:schemeClr>
+            </a:gs>
+          </a:gsLst>
+          <a:lin ang="16200000" scaled="0"/>
+        </a:gradFill>
+      </a:fillStyleLst>
+      <a:lnStyleLst>
+        <a:ln w="9525" cap="flat" cmpd="sng" algn="ctr">
+          <a:solidFill>
+            <a:schemeClr val="phClr">
+              <a:shade val="95000"/>
+              <a:satMod val="105000"/>
+            </a:schemeClr>
+          </a:solidFill>
+          <a:prstDash val="solid"/>
+        </a:ln>
+        <a:ln w="25400" cap="flat" cmpd="sng" algn="ctr">
+          <a:solidFill>
+            <a:schemeClr val="phClr"/>
+          </a:solidFill>
+          <a:prstDash val="solid"/>
+        </a:ln>
+        <a:ln w="38100" cap="flat" cmpd="sng" algn="ctr">
+          <a:solidFill>
+            <a:schemeClr val="phClr"/>
+          </a:solidFill>
+          <a:prstDash val="solid"/>
+        </a:ln>
+      </a:lnStyleLst>
+      <a:effectStyleLst>
+        <a:effectStyle>
+          <a:effectLst>
+            <a:outerShdw blurRad="40000" dist="20000" dir="5400000" rotWithShape="0">
+              <a:srgbClr val="000000">
+                <a:alpha val="38000"/>
+              </a:srgbClr>
+            </a:outerShdw>
+          </a:effectLst>
+        </a:effectStyle>
+        <a:effectStyle>
+          <a:effectLst>
+            <a:outerShdw blurRad="40000" dist="23000" dir="5400000" rotWithShape="0">
+              <a:srgbClr val="000000">
+                <a:alpha val="35000"/>
+              </a:srgbClr>
+            </a:outerShdw>
+          </a:effectLst>
+        </a:effectStyle>
+        <a:effectStyle>
+          <a:effectLst>
+            <a:outerShdw blurRad="40000" dist="23000" dir="5400000" rotWithShape="0">
+              <a:srgbClr val="000000">
+                <a:alpha val="35000"/>
+              </a:srgbClr>
+            </a:outerShdw>
+          </a:effectLst>
+          <a:scene3d>
+            <a:camera prst="orthographicFront">
+              <a:rot lat="0" lon="0" rev="0"/>
+            </a:camera>
+            <a:lightRig rig="threePt" dir="t">
+              <a:rot lat="0" lon="0" rev="1200000"/>
+            </a:lightRig>
+          </a:scene3d>
+          <a:sp3d>
+            <a:bevelT w="63500" h="25400"/>
+          </a:sp3d>
+        </a:effectStyle>
+      </a:effectStyleLst>
+      <a:bgFillStyleLst>
+        <a:solidFill>
+          <a:schemeClr val="phClr"/>
+        </a:solidFill>
+        <a:gradFill rotWithShape="1">
+          <a:gsLst>
+            <a:gs pos="0">
+              <a:schemeClr val="phClr">
+                <a:tint val="40000"/>
+                <a:satMod val="350000"/>
+              </a:schemeClr>
+            </a:gs>
+            <a:gs pos="40000">
+              <a:schemeClr val="phClr">
+                <a:tint val="45000"/>
+                <a:shade val="99000"/>
+                <a:satMod val="350000"/>
+              </a:schemeClr>
+            </a:gs>
+            <a:gs pos="100000">
+              <a:schemeClr val="phClr">
+                <a:shade val="20000"/>
+                <a:satMod val="255000"/>
+              </a:schemeClr>
+            </a:gs>
+          </a:gsLst>
+          <a:path path="circle">
+            <a:fillToRect l="50000" t="-80000" r="50000" b="180000"/>
+          </a:path>
+        </a:gradFill>
+        <a:gradFill rotWithShape="1">
+          <a:gsLst>
+            <a:gs pos="0">
+              <a:schemeClr val="phClr">
+                <a:tint val="80000"/>
+                <a:satMod val="300000"/>
+              </a:schemeClr>
+            </a:gs>
+            <a:gs pos="100000">
+              <a:schemeClr val="phClr">
+                <a:shade val="30000"/>
+                <a:satMod val="200000"/>
+              </a:schemeClr>
+            </a:gs>
+          </a:gsLst>
+          <a:path path="circle">
+            <a:fillToRect l="50000" t="50000" r="50000" b="50000"/>
+          </a:path>
+        </a:gradFill>
+      </a:bgFillStyleLst>
+    </a:fmtScheme>
+  </a:themeElements>
+  <a:objectDefaults>
+    <a:spDef>
+      <a:spPr/>
+      <a:bodyPr/>
+      <a:lstStyle/>
+      <a:style>
+        <a:lnRef idx="1">
+          <a:schemeClr val="accent1"/>
+        </a:lnRef>
+        <a:fillRef idx="3">
+          <a:schemeClr val="accent1"/>
+        </a:fillRef>
+        <a:effectRef idx="2">
+          <a:schemeClr val="accent1"/>
+        </a:effectRef>
+        <a:fontRef idx="minor">
+          <a:schemeClr val="lt1"/>
+        </a:fontRef>
+      </a:style>
+    </a:spDef>
+    <a:lnDef>
+      <a:spPr/>
+      <a:bodyPr/>
+      <a:lstStyle/>
+      <a:style>
+        <a:lnRef idx="2">
+          <a:schemeClr val="accent1"/>
+        </a:lnRef>
+        <a:fillRef idx="0">
+          <a:schemeClr val="accent1"/>
+        </a:fillRef>
+        <a:effectRef idx="1">
+          <a:schemeClr val="accent1"/>
+        </a:effectRef>
+        <a:fontRef idx="minor">
+          <a:schemeClr val="tx1"/>
+        </a:fontRef>
+      </a:style>
+    </a:lnDef>
+  </a:objectDefaults>
+  <a:extraClrSchemeLst/>
+</a:theme>
 </file>
</xml_diff>

<commit_message>
Add system architecture slide with presenter notes
</commit_message>
<xml_diff>
--- a/GraphJudge_Presentation.pptx
+++ b/GraphJudge_Presentation.pptx
@@ -18,6 +18,7 @@
     <p:sldId id="266" r:id="rId17"/>
     <p:sldId id="267" r:id="rId18"/>
     <p:sldId id="268" r:id="rId19"/>
+    <p:sldId id="269" r:id="rId20"/>
   </p:sldIdLst>
   <p:sldSz cx="12191695" cy="6858000" type="screen4x3"/>
   <p:notesSz cx="6858000" cy="9144000"/>
@@ -584,7 +585,7 @@
           <a:lstStyle/>
           <a:p>
             <a:r>
-              <a:t>This is our own hands-on work from this week, not the paper. I cloned the official repo, fixed a small device bug for Mac, ran an extraction pass on 15 SCIERC abstracts, then a strict filtering pass, and scored both with the paper's own metric code. Filtering raised precision on every metric, that is the graph judge effect reproduced. But my crude filter also deleted correct triples so recall fell. That is exactly why they fine-tune a judge instead of using rules. Sumanth is leading the triplet accuracy checking that Professor Tao assigned, and this experiment supports that direction directly.</a:t>
+              <a:t>This slide is about evaluation, which Professor Tao called the most challenging part. Exact string match is too harsh, part of versus component of should not count as wrong, so the field uses soft metrics, and G-BERTScore with embeddings is the headline one. The catch for us: every metric here needs a gold reference graph, and no gold KG exists for animal science. So one of our first team tasks is hand-building a small gold set. I would like the group's input on how we split that labeling work.</a:t>
             </a:r>
           </a:p>
         </p:txBody>
@@ -654,7 +655,7 @@
           <a:lstStyle/>
           <a:p>
             <a:r>
-              <a:t>Mapping to our project. From what Sumanth explained to me about the KGCompass plan: the capstone side builds the animal science KG, and the directed studies side produces the research, evaluating construction approaches and pruning. GraphJudge gives us the recipe: over-generate, judge, filter. The gold set we label as a team does double duty, judge training data and evaluation standard. And the released weights mean we can demo a judge before training anything.</a:t>
+              <a:t>This is our own hands-on work from this week, not the paper. I cloned the official repo, fixed a small device bug for Mac, ran an extraction pass on 15 SCIERC abstracts, then a strict filtering pass, and scored both with the paper's own metric code. Filtering raised precision on every metric, that is the graph judge effect reproduced. But my crude filter also deleted correct triples so recall fell. That is exactly why they fine-tune a judge instead of using rules. Sumanth is leading the triplet accuracy checking that Professor Tao assigned, and this experiment supports that direction directly.</a:t>
             </a:r>
           </a:p>
         </p:txBody>
@@ -724,7 +725,7 @@
           <a:lstStyle/>
           <a:p>
             <a:r>
-              <a:t>Reading critically, the authors admit three limitations, and each one is a paper opportunity for us: richer knowledge units beyond flat triples, evaluation without gold graphs, and the judge being weaker on specialized text, SCIERC 0.63 versus 0.92 on general text, which says domain gold data matters. Sumanth also mentioned the pruning idea, removing low value nodes to improve accuracy, which fits here as the post-construction complement to judge filtering.</a:t>
+              <a:t>Mapping to our project. From what Sumanth explained to me about the KGCompass plan: the capstone side builds the animal science KG, and the directed studies side produces the research, evaluating construction approaches and pruning. GraphJudge gives us the recipe: over-generate, judge, filter. The gold set we label as a team does double duty, judge training data and evaluation standard. And the released weights mean we can demo a judge before training anything.</a:t>
             </a:r>
           </a:p>
         </p:txBody>
@@ -794,6 +795,76 @@
           <a:lstStyle/>
           <a:p>
             <a:r>
+              <a:t>Reading critically, the authors admit three limitations, and each one is a paper opportunity for us: richer knowledge units beyond flat triples, evaluation without gold graphs, and the judge being weaker on specialized text, SCIERC 0.63 versus 0.92 on general text, which says domain gold data matters. Sumanth also mentioned the pruning idea, removing low value nodes to improve accuracy, which fits here as the post-construction complement to judge filtering.</a:t>
+            </a:r>
+          </a:p>
+        </p:txBody>
+      </p:sp>
+      <p:sp>
+        <p:nvSpPr>
+          <p:cNvPr id="4" name="Slide Number Placeholder 3"/>
+          <p:cNvSpPr>
+            <a:spLocks noGrp="1"/>
+          </p:cNvSpPr>
+          <p:nvPr>
+            <p:ph type="sldNum" idx="5" sz="quarter"/>
+          </p:nvPr>
+        </p:nvSpPr>
+        <p:spPr/>
+      </p:sp>
+    </p:spTree>
+  </p:cSld>
+  <p:clrMapOvr>
+    <a:masterClrMapping/>
+  </p:clrMapOvr>
+</p:notes>
+</file>
+
+<file path=ppt/notesSlides/notesSlide14.xml><?xml version="1.0" encoding="utf-8"?>
+<p:notes xmlns:a="http://schemas.openxmlformats.org/drawingml/2006/main" xmlns:p="http://schemas.openxmlformats.org/presentationml/2006/main" xmlns:r="http://schemas.openxmlformats.org/officeDocument/2006/relationships">
+  <p:cSld>
+    <p:spTree>
+      <p:nvGrpSpPr>
+        <p:cNvPr id="1" name=""/>
+        <p:cNvGrpSpPr/>
+        <p:nvPr/>
+      </p:nvGrpSpPr>
+      <p:grpSpPr>
+        <a:xfrm>
+          <a:off x="0" y="0"/>
+          <a:ext cx="0" cy="0"/>
+          <a:chOff x="0" y="0"/>
+          <a:chExt cx="0" cy="0"/>
+        </a:xfrm>
+      </p:grpSpPr>
+      <p:sp>
+        <p:nvSpPr>
+          <p:cNvPr id="2" name="Slide Image Placeholder 1"/>
+          <p:cNvSpPr>
+            <a:spLocks noGrp="1"/>
+          </p:cNvSpPr>
+          <p:nvPr>
+            <p:ph type="sldImg" idx="2"/>
+          </p:nvPr>
+        </p:nvSpPr>
+        <p:spPr/>
+      </p:sp>
+      <p:sp>
+        <p:nvSpPr>
+          <p:cNvPr id="3" name="Notes Placeholder 2"/>
+          <p:cNvSpPr>
+            <a:spLocks noGrp="1"/>
+          </p:cNvSpPr>
+          <p:nvPr>
+            <p:ph type="body" idx="3" sz="quarter"/>
+          </p:nvPr>
+        </p:nvSpPr>
+        <p:spPr/>
+        <p:txBody>
+          <a:bodyPr/>
+          <a:lstStyle/>
+          <a:p>
+            <a:r>
               <a:t>Proposed two month plan. Weeks one and two, full SCIERC reproduction with the released judge weights and HPRC set up. Weeks three and four, assemble the animal science corpus, I understood from Sumanth that Dr. Kaniyamattam will guide the corpus side, and run ECTD over it. Weeks five and six, team labeling sprint and fine-tune the domain judge. Weeks seven and eight, filter the full KG, measure against the gold set, and first pruning experiments. Happy to adjust this with everyone's availability.</a:t>
             </a:r>
           </a:p>
@@ -1144,7 +1215,7 @@
           <a:lstStyle/>
           <a:p>
             <a:r>
-              <a:t>Module one, ECTD. First the LLM lists the entities, then rewrites the document around those entities, which drops ads and noise. Then it extracts as many candidate triples as possible on purpose. The ablation shows why this matters: removing ECTD drops the score from 0.58 to 0.45 on REBEL. Garbage in, garbage out, even with a perfect judge.</a:t>
+              <a:t>This is the full KGCompass system view. Professor Tao shared an AI-generated visual of this architecture in the group, image models garble text, so this is the same three layer structure recreated with clean labels. Bottom layer, data ingestion and ECTD denoising. Middle layer, the knowledge graph itself with the graph judge filtering candidate triples and the retrieval engine, plus the pruning step. Top layer, the LLM that assembles graph context and answers with citations. The right rail is the user loop, a query goes down to retrieval and a cited answer comes back.</a:t>
             </a:r>
           </a:p>
         </p:txBody>
@@ -1214,7 +1285,7 @@
           <a:lstStyle/>
           <a:p>
             <a:r>
-              <a:t>Module two, how the judge is trained. Positives are real triples from gold graphs, negatives are the same triples with the tail entity swapped randomly. Each training example shows the document and asks yes or no about one triple. The prompt on the right is copied from the paper appendix, we can reuse it almost as is for animal science.</a:t>
+              <a:t>Module one, ECTD. First the LLM lists the entities, then rewrites the document around those entities, which drops ads and noise. Then it extracts as many candidate triples as possible on purpose. The ablation shows why this matters: removing ECTD drops the score from 0.58 to 0.45 on REBEL. Garbage in, garbage out, even with a perfect judge.</a:t>
             </a:r>
           </a:p>
         </p:txBody>
@@ -1284,7 +1355,7 @@
           <a:lstStyle/>
           <a:p>
             <a:r>
-              <a:t>Results across four benchmarks, the metric is G-BERTScore F1, semantic matching. GraphJudge is best everywhere. Two takeaways worth saying out loud: a 7B judge beats PiVe which uses a 70B verifier, and it beats plain GPT-4o, so this is better AND much cheaper. Also the judge transfers across datasets, trained on one corpus it still helps on others.</a:t>
+              <a:t>Module two, how the judge is trained. Positives are real triples from gold graphs, negatives are the same triples with the tail entity swapped randomly. Each training example shows the document and asks yes or no about one triple. The prompt on the right is copied from the paper appendix, we can reuse it almost as is for animal science.</a:t>
             </a:r>
           </a:p>
         </p:txBody>
@@ -1354,7 +1425,7 @@
           <a:lstStyle/>
           <a:p>
             <a:r>
-              <a:t>This slide is about evaluation, which Professor Tao called the most challenging part. Exact string match is too harsh, part of versus component of should not count as wrong, so the field uses soft metrics, and G-BERTScore with embeddings is the headline one. The catch for us: every metric here needs a gold reference graph, and no gold KG exists for animal science. So one of our first team tasks is hand-building a small gold set. I would like the group's input on how we split that labeling work.</a:t>
+              <a:t>Results across four benchmarks, the metric is G-BERTScore F1, semantic matching. GraphJudge is best everywhere. Two takeaways worth saying out loud: a 7B judge beats PiVe which uses a 70B verifier, and it beats plain GPT-4o, so this is better AND much cheaper. Also the judge transfers across datasets, trained on one corpus it still helps on others.</a:t>
             </a:r>
           </a:p>
         </p:txBody>
@@ -4553,7 +4624,7 @@
                 </a:solidFill>
                 <a:latin typeface="Consolas"/>
               </a:rPr>
-              <a:t>1 / 13</a:t>
+              <a:t>1 / 14</a:t>
             </a:r>
           </a:p>
         </p:txBody>
@@ -4567,6 +4638,301 @@
 </file>
 
 <file path=ppt/slides/slide10.xml><?xml version="1.0" encoding="utf-8"?>
+<p:sld xmlns:a="http://schemas.openxmlformats.org/drawingml/2006/main" xmlns:p="http://schemas.openxmlformats.org/presentationml/2006/main" xmlns:r="http://schemas.openxmlformats.org/officeDocument/2006/relationships">
+  <p:cSld>
+    <p:spTree>
+      <p:nvGrpSpPr>
+        <p:cNvPr id="1" name=""/>
+        <p:cNvGrpSpPr/>
+        <p:nvPr/>
+      </p:nvGrpSpPr>
+      <p:grpSpPr/>
+      <p:sp>
+        <p:nvSpPr>
+          <p:cNvPr id="2" name="TextBox 1"/>
+          <p:cNvSpPr txBox="1"/>
+          <p:nvPr/>
+        </p:nvSpPr>
+        <p:spPr>
+          <a:xfrm>
+            <a:off x="548640" y="320040"/>
+            <a:ext cx="10972800" cy="365760"/>
+          </a:xfrm>
+          <a:prstGeom prst="rect">
+            <a:avLst/>
+          </a:prstGeom>
+          <a:noFill/>
+        </p:spPr>
+        <p:txBody>
+          <a:bodyPr wrap="square">
+            <a:spAutoFit/>
+          </a:bodyPr>
+          <a:lstStyle/>
+          <a:p>
+            <a:r>
+              <a:rPr sz="1200" b="1" i="0">
+                <a:solidFill>
+                  <a:srgbClr val="3B4CC0"/>
+                </a:solidFill>
+                <a:latin typeface="Consolas"/>
+              </a:rPr>
+              <a:t>EVALUATION — PROF. TAO'S HARD PART</a:t>
+            </a:r>
+          </a:p>
+        </p:txBody>
+      </p:sp>
+      <p:sp>
+        <p:nvSpPr>
+          <p:cNvPr id="3" name="TextBox 2"/>
+          <p:cNvSpPr txBox="1"/>
+          <p:nvPr/>
+        </p:nvSpPr>
+        <p:spPr>
+          <a:xfrm>
+            <a:off x="548640" y="685800"/>
+            <a:ext cx="11064240" cy="868680"/>
+          </a:xfrm>
+          <a:prstGeom prst="rect">
+            <a:avLst/>
+          </a:prstGeom>
+          <a:noFill/>
+        </p:spPr>
+        <p:txBody>
+          <a:bodyPr wrap="square">
+            <a:spAutoFit/>
+          </a:bodyPr>
+          <a:lstStyle/>
+          <a:p>
+            <a:r>
+              <a:rPr sz="3000" b="1" i="0">
+                <a:solidFill>
+                  <a:srgbClr val="1B2530"/>
+                </a:solidFill>
+                <a:latin typeface="Georgia"/>
+              </a:rPr>
+              <a:t>How do you score a generated graph?</a:t>
+            </a:r>
+          </a:p>
+        </p:txBody>
+      </p:sp>
+      <p:sp>
+        <p:nvSpPr>
+          <p:cNvPr id="4" name="TextBox 3"/>
+          <p:cNvSpPr txBox="1"/>
+          <p:nvPr/>
+        </p:nvSpPr>
+        <p:spPr>
+          <a:xfrm>
+            <a:off x="548640" y="1783080"/>
+            <a:ext cx="5760720" cy="4297680"/>
+          </a:xfrm>
+          <a:prstGeom prst="rect">
+            <a:avLst/>
+          </a:prstGeom>
+          <a:noFill/>
+        </p:spPr>
+        <p:txBody>
+          <a:bodyPr wrap="square">
+            <a:spAutoFit/>
+          </a:bodyPr>
+          <a:lstStyle/>
+          <a:p>
+            <a:pPr>
+              <a:spcAft>
+                <a:spcPts val="800"/>
+              </a:spcAft>
+            </a:pPr>
+            <a:r>
+              <a:rPr sz="1500" b="0" i="0">
+                <a:solidFill>
+                  <a:srgbClr val="1B2530"/>
+                </a:solidFill>
+                <a:latin typeface="Calibri"/>
+              </a:rPr>
+              <a:t>• Triple Match F1 — exact string match. Harsh: "part of" vs "component of" counts as wrong.</a:t>
+            </a:r>
+          </a:p>
+          <a:p>
+            <a:pPr>
+              <a:spcAft>
+                <a:spcPts val="800"/>
+              </a:spcAft>
+            </a:pPr>
+            <a:r>
+              <a:rPr sz="1500" b="0" i="0">
+                <a:solidFill>
+                  <a:srgbClr val="1B2530"/>
+                </a:solidFill>
+                <a:latin typeface="Calibri"/>
+              </a:rPr>
+              <a:t>• G-BLEU / G-ROUGE — soft n-gram overlap between each predicted edge and its best-matched gold edge.</a:t>
+            </a:r>
+          </a:p>
+          <a:p>
+            <a:pPr>
+              <a:spcAft>
+                <a:spcPts val="1000"/>
+              </a:spcAft>
+            </a:pPr>
+            <a:r>
+              <a:rPr sz="1500" b="0" i="0">
+                <a:solidFill>
+                  <a:srgbClr val="1B2530"/>
+                </a:solidFill>
+                <a:latin typeface="Calibri"/>
+              </a:rPr>
+              <a:t>• G-BERTScore — embedding similarity per edge: synonyms get credit. The headline metric.</a:t>
+            </a:r>
+          </a:p>
+          <a:p>
+            <a:pPr>
+              <a:spcAft>
+                <a:spcPts val="600"/>
+              </a:spcAft>
+            </a:pPr>
+            <a:r>
+              <a:rPr sz="1500" b="1" i="0">
+                <a:solidFill>
+                  <a:srgbClr val="3B4CC0"/>
+                </a:solidFill>
+                <a:latin typeface="Calibri"/>
+              </a:rPr>
+              <a:t>All of these need a GOLD reference graph. For animal science, none exists — we must hand-build a small one, or we cannot measure anything.</a:t>
+            </a:r>
+          </a:p>
+        </p:txBody>
+      </p:sp>
+      <p:sp>
+        <p:nvSpPr>
+          <p:cNvPr id="5" name="TextBox 4"/>
+          <p:cNvSpPr txBox="1"/>
+          <p:nvPr/>
+        </p:nvSpPr>
+        <p:spPr>
+          <a:xfrm>
+            <a:off x="6675120" y="1783080"/>
+            <a:ext cx="4937760" cy="4297680"/>
+          </a:xfrm>
+          <a:prstGeom prst="rect">
+            <a:avLst/>
+          </a:prstGeom>
+          <a:noFill/>
+        </p:spPr>
+        <p:txBody>
+          <a:bodyPr wrap="square">
+            <a:spAutoFit/>
+          </a:bodyPr>
+          <a:lstStyle/>
+          <a:p>
+            <a:pPr>
+              <a:spcAft>
+                <a:spcPts val="600"/>
+              </a:spcAft>
+            </a:pPr>
+            <a:r>
+              <a:rPr sz="1300" b="0" i="0">
+                <a:solidFill>
+                  <a:srgbClr val="5E6B7A"/>
+                </a:solidFill>
+                <a:latin typeface="Calibri"/>
+              </a:rPr>
+              <a:t>Why exact match is not enough:</a:t>
+            </a:r>
+          </a:p>
+          <a:p>
+            <a:pPr>
+              <a:spcAft>
+                <a:spcPts val="600"/>
+              </a:spcAft>
+            </a:pPr>
+            <a:r>
+              <a:rPr sz="1200" b="0" i="0">
+                <a:solidFill>
+                  <a:srgbClr val="0E7C5B"/>
+                </a:solidFill>
+                <a:latin typeface="Consolas"/>
+              </a:rPr>
+              <a:t>gold:  (morphological analysis — used for — Japanese text processing)</a:t>
+            </a:r>
+          </a:p>
+          <a:p>
+            <a:pPr>
+              <a:spcAft>
+                <a:spcPts val="600"/>
+              </a:spcAft>
+            </a:pPr>
+            <a:r>
+              <a:rPr sz="1200" b="0" i="0">
+                <a:solidFill>
+                  <a:srgbClr val="1B2530"/>
+                </a:solidFill>
+                <a:latin typeface="Consolas"/>
+              </a:rPr>
+              <a:t>pred:  (morphological analysis — applied to — processing Japanese text)</a:t>
+            </a:r>
+          </a:p>
+          <a:p>
+            <a:pPr>
+              <a:spcAft>
+                <a:spcPts val="600"/>
+              </a:spcAft>
+            </a:pPr>
+            <a:r>
+              <a:rPr sz="1300" b="0" i="0">
+                <a:solidFill>
+                  <a:srgbClr val="5E6B7A"/>
+                </a:solidFill>
+                <a:latin typeface="Calibri"/>
+              </a:rPr>
+              <a:t>0 points on exact match, ~0.9 on G-BERTScore. Semantics over spelling.</a:t>
+            </a:r>
+          </a:p>
+        </p:txBody>
+      </p:sp>
+      <p:sp>
+        <p:nvSpPr>
+          <p:cNvPr id="6" name="TextBox 5"/>
+          <p:cNvSpPr txBox="1"/>
+          <p:nvPr/>
+        </p:nvSpPr>
+        <p:spPr>
+          <a:xfrm>
+            <a:off x="11247120" y="6446520"/>
+            <a:ext cx="822960" cy="320040"/>
+          </a:xfrm>
+          <a:prstGeom prst="rect">
+            <a:avLst/>
+          </a:prstGeom>
+          <a:noFill/>
+        </p:spPr>
+        <p:txBody>
+          <a:bodyPr wrap="square">
+            <a:spAutoFit/>
+          </a:bodyPr>
+          <a:lstStyle/>
+          <a:p>
+            <a:pPr algn="r"/>
+            <a:r>
+              <a:rPr sz="1000" b="0" i="0">
+                <a:solidFill>
+                  <a:srgbClr val="5E6B7A"/>
+                </a:solidFill>
+                <a:latin typeface="Consolas"/>
+              </a:rPr>
+              <a:t>10 / 14</a:t>
+            </a:r>
+          </a:p>
+        </p:txBody>
+      </p:sp>
+    </p:spTree>
+  </p:cSld>
+  <p:clrMapOvr>
+    <a:masterClrMapping/>
+  </p:clrMapOvr>
+</p:sld>
+</file>
+
+<file path=ppt/slides/slide11.xml><?xml version="1.0" encoding="utf-8"?>
 <p:sld xmlns:a="http://schemas.openxmlformats.org/drawingml/2006/main" xmlns:p="http://schemas.openxmlformats.org/presentationml/2006/main" xmlns:r="http://schemas.openxmlformats.org/officeDocument/2006/relationships">
   <p:cSld>
     <p:spTree>
@@ -5209,231 +5575,7 @@
                 </a:solidFill>
                 <a:latin typeface="Consolas"/>
               </a:rPr>
-              <a:t>10 / 13</a:t>
-            </a:r>
-          </a:p>
-        </p:txBody>
-      </p:sp>
-    </p:spTree>
-  </p:cSld>
-  <p:clrMapOvr>
-    <a:masterClrMapping/>
-  </p:clrMapOvr>
-</p:sld>
-</file>
-
-<file path=ppt/slides/slide11.xml><?xml version="1.0" encoding="utf-8"?>
-<p:sld xmlns:a="http://schemas.openxmlformats.org/drawingml/2006/main" xmlns:p="http://schemas.openxmlformats.org/presentationml/2006/main" xmlns:r="http://schemas.openxmlformats.org/officeDocument/2006/relationships">
-  <p:cSld>
-    <p:spTree>
-      <p:nvGrpSpPr>
-        <p:cNvPr id="1" name=""/>
-        <p:cNvGrpSpPr/>
-        <p:nvPr/>
-      </p:nvGrpSpPr>
-      <p:grpSpPr/>
-      <p:sp>
-        <p:nvSpPr>
-          <p:cNvPr id="2" name="TextBox 1"/>
-          <p:cNvSpPr txBox="1"/>
-          <p:nvPr/>
-        </p:nvSpPr>
-        <p:spPr>
-          <a:xfrm>
-            <a:off x="548640" y="320040"/>
-            <a:ext cx="10972800" cy="365760"/>
-          </a:xfrm>
-          <a:prstGeom prst="rect">
-            <a:avLst/>
-          </a:prstGeom>
-          <a:noFill/>
-        </p:spPr>
-        <p:txBody>
-          <a:bodyPr wrap="square">
-            <a:spAutoFit/>
-          </a:bodyPr>
-          <a:lstStyle/>
-          <a:p>
-            <a:r>
-              <a:rPr sz="1200" b="1" i="0">
-                <a:solidFill>
-                  <a:srgbClr val="3B4CC0"/>
-                </a:solidFill>
-                <a:latin typeface="Consolas"/>
-              </a:rPr>
-              <a:t>MAPPING TO KGCOMPASS</a:t>
-            </a:r>
-          </a:p>
-        </p:txBody>
-      </p:sp>
-      <p:sp>
-        <p:nvSpPr>
-          <p:cNvPr id="3" name="TextBox 2"/>
-          <p:cNvSpPr txBox="1"/>
-          <p:nvPr/>
-        </p:nvSpPr>
-        <p:spPr>
-          <a:xfrm>
-            <a:off x="548640" y="685800"/>
-            <a:ext cx="11064240" cy="868680"/>
-          </a:xfrm>
-          <a:prstGeom prst="rect">
-            <a:avLst/>
-          </a:prstGeom>
-          <a:noFill/>
-        </p:spPr>
-        <p:txBody>
-          <a:bodyPr wrap="square">
-            <a:spAutoFit/>
-          </a:bodyPr>
-          <a:lstStyle/>
-          <a:p>
-            <a:r>
-              <a:rPr sz="3000" b="1" i="0">
-                <a:solidFill>
-                  <a:srgbClr val="1B2530"/>
-                </a:solidFill>
-                <a:latin typeface="Georgia"/>
-              </a:rPr>
-              <a:t>What we take into the animal science KG</a:t>
-            </a:r>
-          </a:p>
-        </p:txBody>
-      </p:sp>
-      <p:sp>
-        <p:nvSpPr>
-          <p:cNvPr id="4" name="TextBox 3"/>
-          <p:cNvSpPr txBox="1"/>
-          <p:nvPr/>
-        </p:nvSpPr>
-        <p:spPr>
-          <a:xfrm>
-            <a:off x="548640" y="1783080"/>
-            <a:ext cx="11064240" cy="4572000"/>
-          </a:xfrm>
-          <a:prstGeom prst="rect">
-            <a:avLst/>
-          </a:prstGeom>
-          <a:noFill/>
-        </p:spPr>
-        <p:txBody>
-          <a:bodyPr wrap="square">
-            <a:spAutoFit/>
-          </a:bodyPr>
-          <a:lstStyle/>
-          <a:p>
-            <a:pPr>
-              <a:spcAft>
-                <a:spcPts val="900"/>
-              </a:spcAft>
-            </a:pPr>
-            <a:r>
-              <a:rPr sz="1500" b="0" i="0">
-                <a:solidFill>
-                  <a:srgbClr val="1B2530"/>
-                </a:solidFill>
-                <a:latin typeface="Calibri"/>
-              </a:rPr>
-              <a:t>• Triplet accuracy first (Prof. Tao's directive) = the Graph Judgement module. Judge each triple directly against its source text; never evaluate through another model's generated content.</a:t>
-            </a:r>
-          </a:p>
-          <a:p>
-            <a:pPr>
-              <a:spcAft>
-                <a:spcPts val="900"/>
-              </a:spcAft>
-            </a:pPr>
-            <a:r>
-              <a:rPr sz="1500" b="0" i="0">
-                <a:solidFill>
-                  <a:srgbClr val="1B2530"/>
-                </a:solidFill>
-                <a:latin typeface="Calibri"/>
-              </a:rPr>
-              <a:t>• Recall then precision: over-generate candidates from the corpus, then filter with a judge — don't try to extract perfectly in one pass.</a:t>
-            </a:r>
-          </a:p>
-          <a:p>
-            <a:pPr>
-              <a:spcAft>
-                <a:spcPts val="900"/>
-              </a:spcAft>
-            </a:pPr>
-            <a:r>
-              <a:rPr sz="1500" b="0" i="0">
-                <a:solidFill>
-                  <a:srgbClr val="1B2530"/>
-                </a:solidFill>
-                <a:latin typeface="Calibri"/>
-              </a:rPr>
-              <a:t>• Train a domain judge: hand-label a small gold set of animal science triples as a team — it doubles as judge training data and our evaluation gold standard.</a:t>
-            </a:r>
-          </a:p>
-          <a:p>
-            <a:pPr>
-              <a:spcAft>
-                <a:spcPts val="900"/>
-              </a:spcAft>
-            </a:pPr>
-            <a:r>
-              <a:rPr sz="1500" b="0" i="0">
-                <a:solidFill>
-                  <a:srgbClr val="1B2530"/>
-                </a:solidFill>
-                <a:latin typeface="Calibri"/>
-              </a:rPr>
-              <a:t>• Cheap to run: released LoRA weights exist (HuggingFace: HaoyuHuang2/graphjudger); our own fine-tune fits a single HPRC GPU.</a:t>
-            </a:r>
-          </a:p>
-          <a:p>
-            <a:pPr>
-              <a:spcAft>
-                <a:spcPts val="600"/>
-              </a:spcAft>
-            </a:pPr>
-            <a:r>
-              <a:rPr sz="1500" b="0" i="0">
-                <a:solidFill>
-                  <a:srgbClr val="1B2530"/>
-                </a:solidFill>
-                <a:latin typeface="Calibri"/>
-              </a:rPr>
-              <a:t>• Open angles: richer knowledge units beyond flat triples · evaluation without gold graphs · pruning after construction (complementary to judge-filtering during construction).</a:t>
-            </a:r>
-          </a:p>
-        </p:txBody>
-      </p:sp>
-      <p:sp>
-        <p:nvSpPr>
-          <p:cNvPr id="5" name="TextBox 4"/>
-          <p:cNvSpPr txBox="1"/>
-          <p:nvPr/>
-        </p:nvSpPr>
-        <p:spPr>
-          <a:xfrm>
-            <a:off x="11247120" y="6446520"/>
-            <a:ext cx="822960" cy="320040"/>
-          </a:xfrm>
-          <a:prstGeom prst="rect">
-            <a:avLst/>
-          </a:prstGeom>
-          <a:noFill/>
-        </p:spPr>
-        <p:txBody>
-          <a:bodyPr wrap="square">
-            <a:spAutoFit/>
-          </a:bodyPr>
-          <a:lstStyle/>
-          <a:p>
-            <a:pPr algn="r"/>
-            <a:r>
-              <a:rPr sz="1000" b="0" i="0">
-                <a:solidFill>
-                  <a:srgbClr val="5E6B7A"/>
-                </a:solidFill>
-                <a:latin typeface="Consolas"/>
-              </a:rPr>
-              <a:t>11 / 13</a:t>
+              <a:t>11 / 14</a:t>
             </a:r>
           </a:p>
         </p:txBody>
@@ -5485,7 +5627,7 @@
                 </a:solidFill>
                 <a:latin typeface="Consolas"/>
               </a:rPr>
-              <a:t>READ CRITICALLY</a:t>
+              <a:t>MAPPING TO KGCOMPASS</a:t>
             </a:r>
           </a:p>
         </p:txBody>
@@ -5519,7 +5661,7 @@
                 </a:solidFill>
                 <a:latin typeface="Georgia"/>
               </a:rPr>
-              <a:t>Limitations the authors admit — our opportunities</a:t>
+              <a:t>What we take into the animal science KG</a:t>
             </a:r>
           </a:p>
         </p:txBody>
@@ -5533,7 +5675,7 @@
         <p:spPr>
           <a:xfrm>
             <a:off x="548640" y="1783080"/>
-            <a:ext cx="5760720" cy="4206240"/>
+            <a:ext cx="11064240" cy="4572000"/>
           </a:xfrm>
           <a:prstGeom prst="rect">
             <a:avLst/>
@@ -5558,7 +5700,7 @@
                 </a:solidFill>
                 <a:latin typeface="Calibri"/>
               </a:rPr>
-              <a:t>• Only flat entity-level triples; no n-ary relations, events, or time.</a:t>
+              <a:t>• Triplet accuracy first (Prof. Tao's directive) = the Graph Judgement module. Judge each triple directly against its source text; never evaluate through another model's generated content.</a:t>
             </a:r>
           </a:p>
           <a:p>
@@ -5574,7 +5716,39 @@
                 </a:solidFill>
                 <a:latin typeface="Calibri"/>
               </a:rPr>
-              <a:t>• "Gold" KGs used for scoring are themselves imperfect; the field lacks a self-supervised way to evaluate.</a:t>
+              <a:t>• Recall then precision: over-generate candidates from the corpus, then filter with a judge — don't try to extract perfectly in one pass.</a:t>
+            </a:r>
+          </a:p>
+          <a:p>
+            <a:pPr>
+              <a:spcAft>
+                <a:spcPts val="900"/>
+              </a:spcAft>
+            </a:pPr>
+            <a:r>
+              <a:rPr sz="1500" b="0" i="0">
+                <a:solidFill>
+                  <a:srgbClr val="1B2530"/>
+                </a:solidFill>
+                <a:latin typeface="Calibri"/>
+              </a:rPr>
+              <a:t>• Train a domain judge: hand-label a small gold set of animal science triples as a team — it doubles as judge training data and our evaluation gold standard.</a:t>
+            </a:r>
+          </a:p>
+          <a:p>
+            <a:pPr>
+              <a:spcAft>
+                <a:spcPts val="900"/>
+              </a:spcAft>
+            </a:pPr>
+            <a:r>
+              <a:rPr sz="1500" b="0" i="0">
+                <a:solidFill>
+                  <a:srgbClr val="1B2530"/>
+                </a:solidFill>
+                <a:latin typeface="Calibri"/>
+              </a:rPr>
+              <a:t>• Cheap to run: released LoRA weights exist (HuggingFace: HaoyuHuang2/graphjudger); our own fine-tune fits a single HPRC GPU.</a:t>
             </a:r>
           </a:p>
           <a:p>
@@ -5590,7 +5764,7 @@
                 </a:solidFill>
                 <a:latin typeface="Calibri"/>
               </a:rPr>
-              <a:t>• Judge accuracy dips on deeply specialized text (SCIERC: 0.63 vs 0.92 general) — domain gold data matters.</a:t>
+              <a:t>• Open angles: richer knowledge units beyond flat triples · evaluation without gold graphs · pruning after construction (complementary to judge-filtering during construction).</a:t>
             </a:r>
           </a:p>
         </p:txBody>
@@ -5598,61 +5772,6 @@
       <p:sp>
         <p:nvSpPr>
           <p:cNvPr id="5" name="TextBox 4"/>
-          <p:cNvSpPr txBox="1"/>
-          <p:nvPr/>
-        </p:nvSpPr>
-        <p:spPr>
-          <a:xfrm>
-            <a:off x="6675120" y="1783080"/>
-            <a:ext cx="4937760" cy="4206240"/>
-          </a:xfrm>
-          <a:prstGeom prst="rect">
-            <a:avLst/>
-          </a:prstGeom>
-          <a:noFill/>
-        </p:spPr>
-        <p:txBody>
-          <a:bodyPr wrap="square">
-            <a:spAutoFit/>
-          </a:bodyPr>
-          <a:lstStyle/>
-          <a:p>
-            <a:pPr>
-              <a:spcAft>
-                <a:spcPts val="1000"/>
-              </a:spcAft>
-            </a:pPr>
-            <a:r>
-              <a:rPr sz="1500" b="1" i="0">
-                <a:solidFill>
-                  <a:srgbClr val="0E7C5B"/>
-                </a:solidFill>
-                <a:latin typeface="Calibri"/>
-              </a:rPr>
-              <a:t>Each limitation is a research question we can own: domain-adapted judges for agriculture, evaluation without gold graphs, metric-driven graph pruning.</a:t>
-            </a:r>
-          </a:p>
-          <a:p>
-            <a:pPr>
-              <a:spcAft>
-                <a:spcPts val="600"/>
-              </a:spcAft>
-            </a:pPr>
-            <a:r>
-              <a:rPr sz="1350" b="0" i="0">
-                <a:solidFill>
-                  <a:srgbClr val="5E6B7A"/>
-                </a:solidFill>
-                <a:latin typeface="Calibri"/>
-              </a:rPr>
-              <a:t>Accepted at EMNLP 2025 Main — peer-reviewed foundation, public code and weights.</a:t>
-            </a:r>
-          </a:p>
-        </p:txBody>
-      </p:sp>
-      <p:sp>
-        <p:nvSpPr>
-          <p:cNvPr id="6" name="TextBox 5"/>
           <p:cNvSpPr txBox="1"/>
           <p:nvPr/>
         </p:nvSpPr>
@@ -5680,7 +5799,7 @@
                 </a:solidFill>
                 <a:latin typeface="Consolas"/>
               </a:rPr>
-              <a:t>12 / 13</a:t>
+              <a:t>12 / 14</a:t>
             </a:r>
           </a:p>
         </p:txBody>
@@ -5732,7 +5851,7 @@
                 </a:solidFill>
                 <a:latin typeface="Consolas"/>
               </a:rPr>
-              <a:t>PROPOSED NEXT STEPS</a:t>
+              <a:t>READ CRITICALLY</a:t>
             </a:r>
           </a:p>
         </p:txBody>
@@ -5766,6 +5885,253 @@
                 </a:solidFill>
                 <a:latin typeface="Georgia"/>
               </a:rPr>
+              <a:t>Limitations the authors admit — our opportunities</a:t>
+            </a:r>
+          </a:p>
+        </p:txBody>
+      </p:sp>
+      <p:sp>
+        <p:nvSpPr>
+          <p:cNvPr id="4" name="TextBox 3"/>
+          <p:cNvSpPr txBox="1"/>
+          <p:nvPr/>
+        </p:nvSpPr>
+        <p:spPr>
+          <a:xfrm>
+            <a:off x="548640" y="1783080"/>
+            <a:ext cx="5760720" cy="4206240"/>
+          </a:xfrm>
+          <a:prstGeom prst="rect">
+            <a:avLst/>
+          </a:prstGeom>
+          <a:noFill/>
+        </p:spPr>
+        <p:txBody>
+          <a:bodyPr wrap="square">
+            <a:spAutoFit/>
+          </a:bodyPr>
+          <a:lstStyle/>
+          <a:p>
+            <a:pPr>
+              <a:spcAft>
+                <a:spcPts val="900"/>
+              </a:spcAft>
+            </a:pPr>
+            <a:r>
+              <a:rPr sz="1500" b="0" i="0">
+                <a:solidFill>
+                  <a:srgbClr val="1B2530"/>
+                </a:solidFill>
+                <a:latin typeface="Calibri"/>
+              </a:rPr>
+              <a:t>• Only flat entity-level triples; no n-ary relations, events, or time.</a:t>
+            </a:r>
+          </a:p>
+          <a:p>
+            <a:pPr>
+              <a:spcAft>
+                <a:spcPts val="900"/>
+              </a:spcAft>
+            </a:pPr>
+            <a:r>
+              <a:rPr sz="1500" b="0" i="0">
+                <a:solidFill>
+                  <a:srgbClr val="1B2530"/>
+                </a:solidFill>
+                <a:latin typeface="Calibri"/>
+              </a:rPr>
+              <a:t>• "Gold" KGs used for scoring are themselves imperfect; the field lacks a self-supervised way to evaluate.</a:t>
+            </a:r>
+          </a:p>
+          <a:p>
+            <a:pPr>
+              <a:spcAft>
+                <a:spcPts val="600"/>
+              </a:spcAft>
+            </a:pPr>
+            <a:r>
+              <a:rPr sz="1500" b="0" i="0">
+                <a:solidFill>
+                  <a:srgbClr val="1B2530"/>
+                </a:solidFill>
+                <a:latin typeface="Calibri"/>
+              </a:rPr>
+              <a:t>• Judge accuracy dips on deeply specialized text (SCIERC: 0.63 vs 0.92 general) — domain gold data matters.</a:t>
+            </a:r>
+          </a:p>
+        </p:txBody>
+      </p:sp>
+      <p:sp>
+        <p:nvSpPr>
+          <p:cNvPr id="5" name="TextBox 4"/>
+          <p:cNvSpPr txBox="1"/>
+          <p:nvPr/>
+        </p:nvSpPr>
+        <p:spPr>
+          <a:xfrm>
+            <a:off x="6675120" y="1783080"/>
+            <a:ext cx="4937760" cy="4206240"/>
+          </a:xfrm>
+          <a:prstGeom prst="rect">
+            <a:avLst/>
+          </a:prstGeom>
+          <a:noFill/>
+        </p:spPr>
+        <p:txBody>
+          <a:bodyPr wrap="square">
+            <a:spAutoFit/>
+          </a:bodyPr>
+          <a:lstStyle/>
+          <a:p>
+            <a:pPr>
+              <a:spcAft>
+                <a:spcPts val="1000"/>
+              </a:spcAft>
+            </a:pPr>
+            <a:r>
+              <a:rPr sz="1500" b="1" i="0">
+                <a:solidFill>
+                  <a:srgbClr val="0E7C5B"/>
+                </a:solidFill>
+                <a:latin typeface="Calibri"/>
+              </a:rPr>
+              <a:t>Each limitation is a research question we can own: domain-adapted judges for agriculture, evaluation without gold graphs, metric-driven graph pruning.</a:t>
+            </a:r>
+          </a:p>
+          <a:p>
+            <a:pPr>
+              <a:spcAft>
+                <a:spcPts val="600"/>
+              </a:spcAft>
+            </a:pPr>
+            <a:r>
+              <a:rPr sz="1350" b="0" i="0">
+                <a:solidFill>
+                  <a:srgbClr val="5E6B7A"/>
+                </a:solidFill>
+                <a:latin typeface="Calibri"/>
+              </a:rPr>
+              <a:t>Accepted at EMNLP 2025 Main — peer-reviewed foundation, public code and weights.</a:t>
+            </a:r>
+          </a:p>
+        </p:txBody>
+      </p:sp>
+      <p:sp>
+        <p:nvSpPr>
+          <p:cNvPr id="6" name="TextBox 5"/>
+          <p:cNvSpPr txBox="1"/>
+          <p:nvPr/>
+        </p:nvSpPr>
+        <p:spPr>
+          <a:xfrm>
+            <a:off x="11247120" y="6446520"/>
+            <a:ext cx="822960" cy="320040"/>
+          </a:xfrm>
+          <a:prstGeom prst="rect">
+            <a:avLst/>
+          </a:prstGeom>
+          <a:noFill/>
+        </p:spPr>
+        <p:txBody>
+          <a:bodyPr wrap="square">
+            <a:spAutoFit/>
+          </a:bodyPr>
+          <a:lstStyle/>
+          <a:p>
+            <a:pPr algn="r"/>
+            <a:r>
+              <a:rPr sz="1000" b="0" i="0">
+                <a:solidFill>
+                  <a:srgbClr val="5E6B7A"/>
+                </a:solidFill>
+                <a:latin typeface="Consolas"/>
+              </a:rPr>
+              <a:t>13 / 14</a:t>
+            </a:r>
+          </a:p>
+        </p:txBody>
+      </p:sp>
+    </p:spTree>
+  </p:cSld>
+  <p:clrMapOvr>
+    <a:masterClrMapping/>
+  </p:clrMapOvr>
+</p:sld>
+</file>
+
+<file path=ppt/slides/slide14.xml><?xml version="1.0" encoding="utf-8"?>
+<p:sld xmlns:a="http://schemas.openxmlformats.org/drawingml/2006/main" xmlns:p="http://schemas.openxmlformats.org/presentationml/2006/main" xmlns:r="http://schemas.openxmlformats.org/officeDocument/2006/relationships">
+  <p:cSld>
+    <p:spTree>
+      <p:nvGrpSpPr>
+        <p:cNvPr id="1" name=""/>
+        <p:cNvGrpSpPr/>
+        <p:nvPr/>
+      </p:nvGrpSpPr>
+      <p:grpSpPr/>
+      <p:sp>
+        <p:nvSpPr>
+          <p:cNvPr id="2" name="TextBox 1"/>
+          <p:cNvSpPr txBox="1"/>
+          <p:nvPr/>
+        </p:nvSpPr>
+        <p:spPr>
+          <a:xfrm>
+            <a:off x="548640" y="320040"/>
+            <a:ext cx="10972800" cy="365760"/>
+          </a:xfrm>
+          <a:prstGeom prst="rect">
+            <a:avLst/>
+          </a:prstGeom>
+          <a:noFill/>
+        </p:spPr>
+        <p:txBody>
+          <a:bodyPr wrap="square">
+            <a:spAutoFit/>
+          </a:bodyPr>
+          <a:lstStyle/>
+          <a:p>
+            <a:r>
+              <a:rPr sz="1200" b="1" i="0">
+                <a:solidFill>
+                  <a:srgbClr val="3B4CC0"/>
+                </a:solidFill>
+                <a:latin typeface="Consolas"/>
+              </a:rPr>
+              <a:t>PROPOSED NEXT STEPS</a:t>
+            </a:r>
+          </a:p>
+        </p:txBody>
+      </p:sp>
+      <p:sp>
+        <p:nvSpPr>
+          <p:cNvPr id="3" name="TextBox 2"/>
+          <p:cNvSpPr txBox="1"/>
+          <p:nvPr/>
+        </p:nvSpPr>
+        <p:spPr>
+          <a:xfrm>
+            <a:off x="548640" y="685800"/>
+            <a:ext cx="11064240" cy="868680"/>
+          </a:xfrm>
+          <a:prstGeom prst="rect">
+            <a:avLst/>
+          </a:prstGeom>
+          <a:noFill/>
+        </p:spPr>
+        <p:txBody>
+          <a:bodyPr wrap="square">
+            <a:spAutoFit/>
+          </a:bodyPr>
+          <a:lstStyle/>
+          <a:p>
+            <a:r>
+              <a:rPr sz="3000" b="1" i="0">
+                <a:solidFill>
+                  <a:srgbClr val="1B2530"/>
+                </a:solidFill>
+                <a:latin typeface="Georgia"/>
+              </a:rPr>
               <a:t>From reproduction to our own results — a 2-month plan</a:t>
             </a:r>
           </a:p>
@@ -5943,7 +6309,7 @@
                 </a:solidFill>
                 <a:latin typeface="Consolas"/>
               </a:rPr>
-              <a:t>13 / 13</a:t>
+              <a:t>14 / 14</a:t>
             </a:r>
           </a:p>
         </p:txBody>
@@ -6238,7 +6604,7 @@
                 </a:solidFill>
                 <a:latin typeface="Consolas"/>
               </a:rPr>
-              <a:t>2 / 13</a:t>
+              <a:t>2 / 14</a:t>
             </a:r>
           </a:p>
         </p:txBody>
@@ -6611,7 +6977,7 @@
                 </a:solidFill>
                 <a:latin typeface="Consolas"/>
               </a:rPr>
-              <a:t>3 / 13</a:t>
+              <a:t>3 / 14</a:t>
             </a:r>
           </a:p>
         </p:txBody>
@@ -6922,7 +7288,7 @@
                 </a:solidFill>
                 <a:latin typeface="Consolas"/>
               </a:rPr>
-              <a:t>4 / 13</a:t>
+              <a:t>4 / 14</a:t>
             </a:r>
           </a:p>
         </p:txBody>
@@ -7263,7 +7629,7 @@
                 </a:solidFill>
                 <a:latin typeface="Consolas"/>
               </a:rPr>
-              <a:t>5 / 13</a:t>
+              <a:t>5 / 14</a:t>
             </a:r>
           </a:p>
         </p:txBody>
@@ -7277,6 +7643,126 @@
 </file>
 
 <file path=ppt/slides/slide6.xml><?xml version="1.0" encoding="utf-8"?>
+<p:sld xmlns:a="http://schemas.openxmlformats.org/drawingml/2006/main" xmlns:p="http://schemas.openxmlformats.org/presentationml/2006/main" xmlns:r="http://schemas.openxmlformats.org/officeDocument/2006/relationships">
+  <p:cSld>
+    <p:spTree>
+      <p:nvGrpSpPr>
+        <p:cNvPr id="1" name=""/>
+        <p:cNvGrpSpPr/>
+        <p:nvPr/>
+      </p:nvGrpSpPr>
+      <p:grpSpPr/>
+      <p:sp>
+        <p:nvSpPr>
+          <p:cNvPr id="2" name="Rectangle 1"/>
+          <p:cNvSpPr/>
+          <p:nvPr/>
+        </p:nvSpPr>
+        <p:spPr>
+          <a:xfrm>
+            <a:off x="0" y="0"/>
+            <a:ext cx="12191695" cy="6858000"/>
+          </a:xfrm>
+          <a:prstGeom prst="rect">
+            <a:avLst/>
+          </a:prstGeom>
+          <a:solidFill>
+            <a:srgbClr val="0B1020"/>
+          </a:solidFill>
+          <a:ln>
+            <a:noFill/>
+          </a:ln>
+        </p:spPr>
+        <p:style>
+          <a:lnRef idx="1">
+            <a:schemeClr val="accent1"/>
+          </a:lnRef>
+          <a:fillRef idx="3">
+            <a:schemeClr val="accent1"/>
+          </a:fillRef>
+          <a:effectRef idx="2">
+            <a:schemeClr val="accent1"/>
+          </a:effectRef>
+          <a:fontRef idx="minor">
+            <a:schemeClr val="lt1"/>
+          </a:fontRef>
+        </p:style>
+        <p:txBody>
+          <a:bodyPr rtlCol="0" anchor="ctr"/>
+          <a:lstStyle/>
+          <a:p>
+            <a:pPr algn="ctr"/>
+          </a:p>
+        </p:txBody>
+      </p:sp>
+      <p:pic>
+        <p:nvPicPr>
+          <p:cNvPr id="3" name="Picture 2" descr="KGCompass_Architecture.png"/>
+          <p:cNvPicPr>
+            <a:picLocks noChangeAspect="1"/>
+          </p:cNvPicPr>
+          <p:nvPr/>
+        </p:nvPicPr>
+        <p:blipFill>
+          <a:blip r:embed="rId2"/>
+          <a:stretch>
+            <a:fillRect/>
+          </a:stretch>
+        </p:blipFill>
+        <p:spPr>
+          <a:xfrm>
+            <a:off x="960120" y="173736"/>
+            <a:ext cx="10354093" cy="6510528"/>
+          </a:xfrm>
+          <a:prstGeom prst="rect">
+            <a:avLst/>
+          </a:prstGeom>
+        </p:spPr>
+      </p:pic>
+      <p:sp>
+        <p:nvSpPr>
+          <p:cNvPr id="4" name="TextBox 3"/>
+          <p:cNvSpPr txBox="1"/>
+          <p:nvPr/>
+        </p:nvSpPr>
+        <p:spPr>
+          <a:xfrm>
+            <a:off x="11247120" y="6446520"/>
+            <a:ext cx="822960" cy="320040"/>
+          </a:xfrm>
+          <a:prstGeom prst="rect">
+            <a:avLst/>
+          </a:prstGeom>
+          <a:noFill/>
+        </p:spPr>
+        <p:txBody>
+          <a:bodyPr wrap="square">
+            <a:spAutoFit/>
+          </a:bodyPr>
+          <a:lstStyle/>
+          <a:p>
+            <a:pPr algn="r"/>
+            <a:r>
+              <a:rPr sz="1000" b="0" i="0">
+                <a:solidFill>
+                  <a:srgbClr val="8FA0BF"/>
+                </a:solidFill>
+                <a:latin typeface="Consolas"/>
+              </a:rPr>
+              <a:t>6 / 14</a:t>
+            </a:r>
+          </a:p>
+        </p:txBody>
+      </p:sp>
+    </p:spTree>
+  </p:cSld>
+  <p:clrMapOvr>
+    <a:masterClrMapping/>
+  </p:clrMapOvr>
+</p:sld>
+</file>
+
+<file path=ppt/slides/slide7.xml><?xml version="1.0" encoding="utf-8"?>
 <p:sld xmlns:a="http://schemas.openxmlformats.org/drawingml/2006/main" xmlns:p="http://schemas.openxmlformats.org/presentationml/2006/main" xmlns:r="http://schemas.openxmlformats.org/officeDocument/2006/relationships">
   <p:cSld>
     <p:spTree>
@@ -7700,7 +8186,7 @@
                 </a:solidFill>
                 <a:latin typeface="Consolas"/>
               </a:rPr>
-              <a:t>6 / 13</a:t>
+              <a:t>7 / 14</a:t>
             </a:r>
           </a:p>
         </p:txBody>
@@ -7713,7 +8199,7 @@
 </p:sld>
 </file>
 
-<file path=ppt/slides/slide7.xml><?xml version="1.0" encoding="utf-8"?>
+<file path=ppt/slides/slide8.xml><?xml version="1.0" encoding="utf-8"?>
 <p:sld xmlns:a="http://schemas.openxmlformats.org/drawingml/2006/main" xmlns:p="http://schemas.openxmlformats.org/presentationml/2006/main" xmlns:r="http://schemas.openxmlformats.org/officeDocument/2006/relationships">
   <p:cSld>
     <p:spTree>
@@ -8011,7 +8497,7 @@
                 </a:solidFill>
                 <a:latin typeface="Consolas"/>
               </a:rPr>
-              <a:t>7 / 13</a:t>
+              <a:t>8 / 14</a:t>
             </a:r>
           </a:p>
         </p:txBody>
@@ -8024,7 +8510,7 @@
 </p:sld>
 </file>
 
-<file path=ppt/slides/slide8.xml><?xml version="1.0" encoding="utf-8"?>
+<file path=ppt/slides/slide9.xml><?xml version="1.0" encoding="utf-8"?>
 <p:sld xmlns:a="http://schemas.openxmlformats.org/drawingml/2006/main" xmlns:p="http://schemas.openxmlformats.org/presentationml/2006/main" xmlns:r="http://schemas.openxmlformats.org/officeDocument/2006/relationships">
   <p:cSld>
     <p:spTree>
@@ -8912,302 +9398,7 @@
                 </a:solidFill>
                 <a:latin typeface="Consolas"/>
               </a:rPr>
-              <a:t>8 / 13</a:t>
-            </a:r>
-          </a:p>
-        </p:txBody>
-      </p:sp>
-    </p:spTree>
-  </p:cSld>
-  <p:clrMapOvr>
-    <a:masterClrMapping/>
-  </p:clrMapOvr>
-</p:sld>
-</file>
-
-<file path=ppt/slides/slide9.xml><?xml version="1.0" encoding="utf-8"?>
-<p:sld xmlns:a="http://schemas.openxmlformats.org/drawingml/2006/main" xmlns:p="http://schemas.openxmlformats.org/presentationml/2006/main" xmlns:r="http://schemas.openxmlformats.org/officeDocument/2006/relationships">
-  <p:cSld>
-    <p:spTree>
-      <p:nvGrpSpPr>
-        <p:cNvPr id="1" name=""/>
-        <p:cNvGrpSpPr/>
-        <p:nvPr/>
-      </p:nvGrpSpPr>
-      <p:grpSpPr/>
-      <p:sp>
-        <p:nvSpPr>
-          <p:cNvPr id="2" name="TextBox 1"/>
-          <p:cNvSpPr txBox="1"/>
-          <p:nvPr/>
-        </p:nvSpPr>
-        <p:spPr>
-          <a:xfrm>
-            <a:off x="548640" y="320040"/>
-            <a:ext cx="10972800" cy="365760"/>
-          </a:xfrm>
-          <a:prstGeom prst="rect">
-            <a:avLst/>
-          </a:prstGeom>
-          <a:noFill/>
-        </p:spPr>
-        <p:txBody>
-          <a:bodyPr wrap="square">
-            <a:spAutoFit/>
-          </a:bodyPr>
-          <a:lstStyle/>
-          <a:p>
-            <a:r>
-              <a:rPr sz="1200" b="1" i="0">
-                <a:solidFill>
-                  <a:srgbClr val="3B4CC0"/>
-                </a:solidFill>
-                <a:latin typeface="Consolas"/>
-              </a:rPr>
-              <a:t>EVALUATION — PROF. TAO'S HARD PART</a:t>
-            </a:r>
-          </a:p>
-        </p:txBody>
-      </p:sp>
-      <p:sp>
-        <p:nvSpPr>
-          <p:cNvPr id="3" name="TextBox 2"/>
-          <p:cNvSpPr txBox="1"/>
-          <p:nvPr/>
-        </p:nvSpPr>
-        <p:spPr>
-          <a:xfrm>
-            <a:off x="548640" y="685800"/>
-            <a:ext cx="11064240" cy="868680"/>
-          </a:xfrm>
-          <a:prstGeom prst="rect">
-            <a:avLst/>
-          </a:prstGeom>
-          <a:noFill/>
-        </p:spPr>
-        <p:txBody>
-          <a:bodyPr wrap="square">
-            <a:spAutoFit/>
-          </a:bodyPr>
-          <a:lstStyle/>
-          <a:p>
-            <a:r>
-              <a:rPr sz="3000" b="1" i="0">
-                <a:solidFill>
-                  <a:srgbClr val="1B2530"/>
-                </a:solidFill>
-                <a:latin typeface="Georgia"/>
-              </a:rPr>
-              <a:t>How do you score a generated graph?</a:t>
-            </a:r>
-          </a:p>
-        </p:txBody>
-      </p:sp>
-      <p:sp>
-        <p:nvSpPr>
-          <p:cNvPr id="4" name="TextBox 3"/>
-          <p:cNvSpPr txBox="1"/>
-          <p:nvPr/>
-        </p:nvSpPr>
-        <p:spPr>
-          <a:xfrm>
-            <a:off x="548640" y="1783080"/>
-            <a:ext cx="5760720" cy="4297680"/>
-          </a:xfrm>
-          <a:prstGeom prst="rect">
-            <a:avLst/>
-          </a:prstGeom>
-          <a:noFill/>
-        </p:spPr>
-        <p:txBody>
-          <a:bodyPr wrap="square">
-            <a:spAutoFit/>
-          </a:bodyPr>
-          <a:lstStyle/>
-          <a:p>
-            <a:pPr>
-              <a:spcAft>
-                <a:spcPts val="800"/>
-              </a:spcAft>
-            </a:pPr>
-            <a:r>
-              <a:rPr sz="1500" b="0" i="0">
-                <a:solidFill>
-                  <a:srgbClr val="1B2530"/>
-                </a:solidFill>
-                <a:latin typeface="Calibri"/>
-              </a:rPr>
-              <a:t>• Triple Match F1 — exact string match. Harsh: "part of" vs "component of" counts as wrong.</a:t>
-            </a:r>
-          </a:p>
-          <a:p>
-            <a:pPr>
-              <a:spcAft>
-                <a:spcPts val="800"/>
-              </a:spcAft>
-            </a:pPr>
-            <a:r>
-              <a:rPr sz="1500" b="0" i="0">
-                <a:solidFill>
-                  <a:srgbClr val="1B2530"/>
-                </a:solidFill>
-                <a:latin typeface="Calibri"/>
-              </a:rPr>
-              <a:t>• G-BLEU / G-ROUGE — soft n-gram overlap between each predicted edge and its best-matched gold edge.</a:t>
-            </a:r>
-          </a:p>
-          <a:p>
-            <a:pPr>
-              <a:spcAft>
-                <a:spcPts val="1000"/>
-              </a:spcAft>
-            </a:pPr>
-            <a:r>
-              <a:rPr sz="1500" b="0" i="0">
-                <a:solidFill>
-                  <a:srgbClr val="1B2530"/>
-                </a:solidFill>
-                <a:latin typeface="Calibri"/>
-              </a:rPr>
-              <a:t>• G-BERTScore — embedding similarity per edge: synonyms get credit. The headline metric.</a:t>
-            </a:r>
-          </a:p>
-          <a:p>
-            <a:pPr>
-              <a:spcAft>
-                <a:spcPts val="600"/>
-              </a:spcAft>
-            </a:pPr>
-            <a:r>
-              <a:rPr sz="1500" b="1" i="0">
-                <a:solidFill>
-                  <a:srgbClr val="3B4CC0"/>
-                </a:solidFill>
-                <a:latin typeface="Calibri"/>
-              </a:rPr>
-              <a:t>All of these need a GOLD reference graph. For animal science, none exists — we must hand-build a small one, or we cannot measure anything.</a:t>
-            </a:r>
-          </a:p>
-        </p:txBody>
-      </p:sp>
-      <p:sp>
-        <p:nvSpPr>
-          <p:cNvPr id="5" name="TextBox 4"/>
-          <p:cNvSpPr txBox="1"/>
-          <p:nvPr/>
-        </p:nvSpPr>
-        <p:spPr>
-          <a:xfrm>
-            <a:off x="6675120" y="1783080"/>
-            <a:ext cx="4937760" cy="4297680"/>
-          </a:xfrm>
-          <a:prstGeom prst="rect">
-            <a:avLst/>
-          </a:prstGeom>
-          <a:noFill/>
-        </p:spPr>
-        <p:txBody>
-          <a:bodyPr wrap="square">
-            <a:spAutoFit/>
-          </a:bodyPr>
-          <a:lstStyle/>
-          <a:p>
-            <a:pPr>
-              <a:spcAft>
-                <a:spcPts val="600"/>
-              </a:spcAft>
-            </a:pPr>
-            <a:r>
-              <a:rPr sz="1300" b="0" i="0">
-                <a:solidFill>
-                  <a:srgbClr val="5E6B7A"/>
-                </a:solidFill>
-                <a:latin typeface="Calibri"/>
-              </a:rPr>
-              <a:t>Why exact match is not enough:</a:t>
-            </a:r>
-          </a:p>
-          <a:p>
-            <a:pPr>
-              <a:spcAft>
-                <a:spcPts val="600"/>
-              </a:spcAft>
-            </a:pPr>
-            <a:r>
-              <a:rPr sz="1200" b="0" i="0">
-                <a:solidFill>
-                  <a:srgbClr val="0E7C5B"/>
-                </a:solidFill>
-                <a:latin typeface="Consolas"/>
-              </a:rPr>
-              <a:t>gold:  (morphological analysis — used for — Japanese text processing)</a:t>
-            </a:r>
-          </a:p>
-          <a:p>
-            <a:pPr>
-              <a:spcAft>
-                <a:spcPts val="600"/>
-              </a:spcAft>
-            </a:pPr>
-            <a:r>
-              <a:rPr sz="1200" b="0" i="0">
-                <a:solidFill>
-                  <a:srgbClr val="1B2530"/>
-                </a:solidFill>
-                <a:latin typeface="Consolas"/>
-              </a:rPr>
-              <a:t>pred:  (morphological analysis — applied to — processing Japanese text)</a:t>
-            </a:r>
-          </a:p>
-          <a:p>
-            <a:pPr>
-              <a:spcAft>
-                <a:spcPts val="600"/>
-              </a:spcAft>
-            </a:pPr>
-            <a:r>
-              <a:rPr sz="1300" b="0" i="0">
-                <a:solidFill>
-                  <a:srgbClr val="5E6B7A"/>
-                </a:solidFill>
-                <a:latin typeface="Calibri"/>
-              </a:rPr>
-              <a:t>0 points on exact match, ~0.9 on G-BERTScore. Semantics over spelling.</a:t>
-            </a:r>
-          </a:p>
-        </p:txBody>
-      </p:sp>
-      <p:sp>
-        <p:nvSpPr>
-          <p:cNvPr id="6" name="TextBox 5"/>
-          <p:cNvSpPr txBox="1"/>
-          <p:nvPr/>
-        </p:nvSpPr>
-        <p:spPr>
-          <a:xfrm>
-            <a:off x="11247120" y="6446520"/>
-            <a:ext cx="822960" cy="320040"/>
-          </a:xfrm>
-          <a:prstGeom prst="rect">
-            <a:avLst/>
-          </a:prstGeom>
-          <a:noFill/>
-        </p:spPr>
-        <p:txBody>
-          <a:bodyPr wrap="square">
-            <a:spAutoFit/>
-          </a:bodyPr>
-          <a:lstStyle/>
-          <a:p>
-            <a:pPr algn="r"/>
-            <a:r>
-              <a:rPr sz="1000" b="0" i="0">
-                <a:solidFill>
-                  <a:srgbClr val="5E6B7A"/>
-                </a:solidFill>
-                <a:latin typeface="Consolas"/>
-              </a:rPr>
-              <a:t>9 / 13</a:t>
+              <a:t>9 / 14</a:t>
             </a:r>
           </a:p>
         </p:txBody>

</xml_diff>